<commit_message>
Redesign: fix layout overlap, increase font sizes, improve contrast
</commit_message>
<xml_diff>
--- a/AI_Agent_CRM_數位轉型方案.pptx
+++ b/AI_Agent_CRM_數位轉型方案.pptx
@@ -3369,7 +3369,7 @@
             <a:pPr algn="l">
               <a:defRPr sz="1600" b="0">
                 <a:solidFill>
-                  <a:srgbClr val="6C757D"/>
+                  <a:srgbClr val="8A94A6"/>
                 </a:solidFill>
                 <a:latin typeface="Microsoft JhengHei"/>
               </a:defRPr>
@@ -3405,7 +3405,7 @@
             <a:pPr algn="l">
               <a:defRPr sz="1400" b="0">
                 <a:solidFill>
-                  <a:srgbClr val="6C757D"/>
+                  <a:srgbClr val="8A94A6"/>
                 </a:solidFill>
                 <a:latin typeface="Microsoft JhengHei"/>
               </a:defRPr>
@@ -3631,8 +3631,8 @@
         </p:nvSpPr>
         <p:spPr>
           <a:xfrm>
-            <a:off x="914400" y="1828800"/>
-            <a:ext cx="10058400" cy="1371600"/>
+            <a:off x="914400" y="457200"/>
+            <a:ext cx="10058400" cy="1097280"/>
           </a:xfrm>
           <a:prstGeom prst="rect">
             <a:avLst/>
@@ -3667,8 +3667,8 @@
         </p:nvSpPr>
         <p:spPr>
           <a:xfrm>
-            <a:off x="914400" y="3200400"/>
-            <a:ext cx="10058400" cy="914400"/>
+            <a:off x="914400" y="1371600"/>
+            <a:ext cx="10058400" cy="731520"/>
           </a:xfrm>
           <a:prstGeom prst="rect">
             <a:avLst/>
@@ -3682,7 +3682,7 @@
           <a:lstStyle/>
           <a:p>
             <a:pPr algn="l">
-              <a:defRPr sz="2000" b="0">
+              <a:defRPr sz="2400" b="0">
                 <a:solidFill>
                   <a:srgbClr val="00B4D8"/>
                 </a:solidFill>
@@ -3703,14 +3703,14 @@
         </p:nvSpPr>
         <p:spPr>
           <a:xfrm>
-            <a:off x="457200" y="1188720"/>
-            <a:ext cx="3566160" cy="4389120"/>
+            <a:off x="457200" y="2103120"/>
+            <a:ext cx="3566160" cy="4114800"/>
           </a:xfrm>
           <a:prstGeom prst="roundRect">
             <a:avLst/>
           </a:prstGeom>
           <a:solidFill>
-            <a:srgbClr val="242A40"/>
+            <a:srgbClr val="2B3045"/>
           </a:solidFill>
           <a:ln>
             <a:noFill/>
@@ -3746,7 +3746,7 @@
         </p:nvSpPr>
         <p:spPr>
           <a:xfrm>
-            <a:off x="457200" y="1188720"/>
+            <a:off x="457200" y="2103120"/>
             <a:ext cx="3566160" cy="73152"/>
           </a:xfrm>
           <a:prstGeom prst="rect">
@@ -3789,7 +3789,7 @@
         </p:nvSpPr>
         <p:spPr>
           <a:xfrm>
-            <a:off x="731520" y="1371600"/>
+            <a:off x="731520" y="2286000"/>
             <a:ext cx="3017520" cy="457200"/>
           </a:xfrm>
           <a:prstGeom prst="rect">
@@ -3825,7 +3825,7 @@
         </p:nvSpPr>
         <p:spPr>
           <a:xfrm>
-            <a:off x="731520" y="1828800"/>
+            <a:off x="731520" y="2743200"/>
             <a:ext cx="3017520" cy="457200"/>
           </a:xfrm>
           <a:prstGeom prst="rect">
@@ -3840,7 +3840,7 @@
           <a:lstStyle/>
           <a:p>
             <a:pPr algn="ctr">
-              <a:defRPr sz="2400" b="1">
+              <a:defRPr sz="2600" b="1">
                 <a:solidFill>
                   <a:srgbClr val="FFFFFF"/>
                 </a:solidFill>
@@ -3861,8 +3861,8 @@
         </p:nvSpPr>
         <p:spPr>
           <a:xfrm>
-            <a:off x="731520" y="2286000"/>
-            <a:ext cx="3017520" cy="2011680"/>
+            <a:off x="731520" y="3291840"/>
+            <a:ext cx="3017520" cy="1645920"/>
           </a:xfrm>
           <a:prstGeom prst="rect">
             <a:avLst/>
@@ -3876,9 +3876,9 @@
           <a:lstStyle/>
           <a:p>
             <a:pPr algn="l">
-              <a:defRPr sz="1300" b="0">
-                <a:solidFill>
-                  <a:srgbClr val="6C757D"/>
+              <a:defRPr sz="1600" b="0">
+                <a:solidFill>
+                  <a:srgbClr val="C0C8D6"/>
                 </a:solidFill>
                 <a:latin typeface="Microsoft JhengHei"/>
               </a:defRPr>
@@ -3913,7 +3913,7 @@
         </p:nvSpPr>
         <p:spPr>
           <a:xfrm>
-            <a:off x="731520" y="4389120"/>
+            <a:off x="731520" y="5120640"/>
             <a:ext cx="3017520" cy="731520"/>
           </a:xfrm>
           <a:prstGeom prst="rect">
@@ -3928,7 +3928,7 @@
           <a:lstStyle/>
           <a:p>
             <a:pPr algn="ctr">
-              <a:defRPr sz="1200" b="0">
+              <a:defRPr sz="1400" b="0">
                 <a:solidFill>
                   <a:srgbClr val="00B4D8"/>
                 </a:solidFill>
@@ -3953,14 +3953,14 @@
         </p:nvSpPr>
         <p:spPr>
           <a:xfrm>
-            <a:off x="4297680" y="1188720"/>
-            <a:ext cx="3566160" cy="4389120"/>
+            <a:off x="4297680" y="2103120"/>
+            <a:ext cx="3566160" cy="4114800"/>
           </a:xfrm>
           <a:prstGeom prst="roundRect">
             <a:avLst/>
           </a:prstGeom>
           <a:solidFill>
-            <a:srgbClr val="242A40"/>
+            <a:srgbClr val="2B3045"/>
           </a:solidFill>
           <a:ln>
             <a:noFill/>
@@ -3996,7 +3996,7 @@
         </p:nvSpPr>
         <p:spPr>
           <a:xfrm>
-            <a:off x="4297680" y="1188720"/>
+            <a:off x="4297680" y="2103120"/>
             <a:ext cx="3566160" cy="73152"/>
           </a:xfrm>
           <a:prstGeom prst="rect">
@@ -4039,7 +4039,7 @@
         </p:nvSpPr>
         <p:spPr>
           <a:xfrm>
-            <a:off x="4572000" y="1371600"/>
+            <a:off x="4572000" y="2286000"/>
             <a:ext cx="3017520" cy="457200"/>
           </a:xfrm>
           <a:prstGeom prst="rect">
@@ -4075,7 +4075,7 @@
         </p:nvSpPr>
         <p:spPr>
           <a:xfrm>
-            <a:off x="4572000" y="1828800"/>
+            <a:off x="4572000" y="2743200"/>
             <a:ext cx="3017520" cy="457200"/>
           </a:xfrm>
           <a:prstGeom prst="rect">
@@ -4090,7 +4090,7 @@
           <a:lstStyle/>
           <a:p>
             <a:pPr algn="ctr">
-              <a:defRPr sz="2400" b="1">
+              <a:defRPr sz="2600" b="1">
                 <a:solidFill>
                   <a:srgbClr val="FFFFFF"/>
                 </a:solidFill>
@@ -4111,8 +4111,8 @@
         </p:nvSpPr>
         <p:spPr>
           <a:xfrm>
-            <a:off x="4572000" y="2286000"/>
-            <a:ext cx="3017520" cy="2011680"/>
+            <a:off x="4572000" y="3291840"/>
+            <a:ext cx="3017520" cy="1645920"/>
           </a:xfrm>
           <a:prstGeom prst="rect">
             <a:avLst/>
@@ -4126,9 +4126,9 @@
           <a:lstStyle/>
           <a:p>
             <a:pPr algn="l">
-              <a:defRPr sz="1300" b="0">
-                <a:solidFill>
-                  <a:srgbClr val="6C757D"/>
+              <a:defRPr sz="1600" b="0">
+                <a:solidFill>
+                  <a:srgbClr val="C0C8D6"/>
                 </a:solidFill>
                 <a:latin typeface="Microsoft JhengHei"/>
               </a:defRPr>
@@ -4163,7 +4163,7 @@
         </p:nvSpPr>
         <p:spPr>
           <a:xfrm>
-            <a:off x="4572000" y="4389120"/>
+            <a:off x="4572000" y="5120640"/>
             <a:ext cx="3017520" cy="731520"/>
           </a:xfrm>
           <a:prstGeom prst="rect">
@@ -4178,7 +4178,7 @@
           <a:lstStyle/>
           <a:p>
             <a:pPr algn="ctr">
-              <a:defRPr sz="1200" b="0">
+              <a:defRPr sz="1400" b="0">
                 <a:solidFill>
                   <a:srgbClr val="00B4D8"/>
                 </a:solidFill>
@@ -4203,14 +4203,14 @@
         </p:nvSpPr>
         <p:spPr>
           <a:xfrm>
-            <a:off x="8138160" y="1188720"/>
-            <a:ext cx="3566160" cy="4389120"/>
+            <a:off x="8138160" y="2103120"/>
+            <a:ext cx="3566160" cy="4114800"/>
           </a:xfrm>
           <a:prstGeom prst="roundRect">
             <a:avLst/>
           </a:prstGeom>
           <a:solidFill>
-            <a:srgbClr val="242A40"/>
+            <a:srgbClr val="2B3045"/>
           </a:solidFill>
           <a:ln>
             <a:noFill/>
@@ -4246,7 +4246,7 @@
         </p:nvSpPr>
         <p:spPr>
           <a:xfrm>
-            <a:off x="8138160" y="1188720"/>
+            <a:off x="8138160" y="2103120"/>
             <a:ext cx="3566160" cy="73152"/>
           </a:xfrm>
           <a:prstGeom prst="rect">
@@ -4289,7 +4289,7 @@
         </p:nvSpPr>
         <p:spPr>
           <a:xfrm>
-            <a:off x="8412480" y="1371600"/>
+            <a:off x="8412480" y="2286000"/>
             <a:ext cx="3017520" cy="457200"/>
           </a:xfrm>
           <a:prstGeom prst="rect">
@@ -4325,7 +4325,7 @@
         </p:nvSpPr>
         <p:spPr>
           <a:xfrm>
-            <a:off x="8412480" y="1828800"/>
+            <a:off x="8412480" y="2743200"/>
             <a:ext cx="3017520" cy="457200"/>
           </a:xfrm>
           <a:prstGeom prst="rect">
@@ -4340,7 +4340,7 @@
           <a:lstStyle/>
           <a:p>
             <a:pPr algn="ctr">
-              <a:defRPr sz="2400" b="1">
+              <a:defRPr sz="2600" b="1">
                 <a:solidFill>
                   <a:srgbClr val="FFFFFF"/>
                 </a:solidFill>
@@ -4361,8 +4361,8 @@
         </p:nvSpPr>
         <p:spPr>
           <a:xfrm>
-            <a:off x="8412480" y="2286000"/>
-            <a:ext cx="3017520" cy="2011680"/>
+            <a:off x="8412480" y="3291840"/>
+            <a:ext cx="3017520" cy="1645920"/>
           </a:xfrm>
           <a:prstGeom prst="rect">
             <a:avLst/>
@@ -4376,9 +4376,9 @@
           <a:lstStyle/>
           <a:p>
             <a:pPr algn="l">
-              <a:defRPr sz="1300" b="0">
-                <a:solidFill>
-                  <a:srgbClr val="6C757D"/>
+              <a:defRPr sz="1600" b="0">
+                <a:solidFill>
+                  <a:srgbClr val="C0C8D6"/>
                 </a:solidFill>
                 <a:latin typeface="Microsoft JhengHei"/>
               </a:defRPr>
@@ -4413,7 +4413,7 @@
         </p:nvSpPr>
         <p:spPr>
           <a:xfrm>
-            <a:off x="8412480" y="4389120"/>
+            <a:off x="8412480" y="5120640"/>
             <a:ext cx="3017520" cy="731520"/>
           </a:xfrm>
           <a:prstGeom prst="rect">
@@ -4428,7 +4428,7 @@
           <a:lstStyle/>
           <a:p>
             <a:pPr algn="ctr">
-              <a:defRPr sz="1200" b="0">
+              <a:defRPr sz="1400" b="0">
                 <a:solidFill>
                   <a:srgbClr val="00B4D8"/>
                 </a:solidFill>
@@ -4522,8 +4522,8 @@
         </p:nvSpPr>
         <p:spPr>
           <a:xfrm>
-            <a:off x="914400" y="1828800"/>
-            <a:ext cx="10058400" cy="1371600"/>
+            <a:off x="914400" y="457200"/>
+            <a:ext cx="10058400" cy="1097280"/>
           </a:xfrm>
           <a:prstGeom prst="rect">
             <a:avLst/>
@@ -4558,8 +4558,8 @@
         </p:nvSpPr>
         <p:spPr>
           <a:xfrm>
-            <a:off x="914400" y="3200400"/>
-            <a:ext cx="10058400" cy="914400"/>
+            <a:off x="914400" y="1371600"/>
+            <a:ext cx="10058400" cy="731520"/>
           </a:xfrm>
           <a:prstGeom prst="rect">
             <a:avLst/>
@@ -4573,7 +4573,7 @@
           <a:lstStyle/>
           <a:p>
             <a:pPr algn="l">
-              <a:defRPr sz="2000" b="0">
+              <a:defRPr sz="2400" b="0">
                 <a:solidFill>
                   <a:srgbClr val="00B4D8"/>
                 </a:solidFill>
@@ -4594,14 +4594,14 @@
         </p:nvSpPr>
         <p:spPr>
           <a:xfrm>
-            <a:off x="457200" y="1188720"/>
-            <a:ext cx="3566160" cy="3200400"/>
+            <a:off x="457200" y="2103120"/>
+            <a:ext cx="3566160" cy="2926080"/>
           </a:xfrm>
           <a:prstGeom prst="roundRect">
             <a:avLst/>
           </a:prstGeom>
           <a:solidFill>
-            <a:srgbClr val="242A40"/>
+            <a:srgbClr val="2B3045"/>
           </a:solidFill>
           <a:ln>
             <a:noFill/>
@@ -4637,7 +4637,7 @@
         </p:nvSpPr>
         <p:spPr>
           <a:xfrm>
-            <a:off x="457200" y="1188720"/>
+            <a:off x="457200" y="2103120"/>
             <a:ext cx="3566160" cy="73152"/>
           </a:xfrm>
           <a:prstGeom prst="rect">
@@ -4680,7 +4680,7 @@
         </p:nvSpPr>
         <p:spPr>
           <a:xfrm>
-            <a:off x="731520" y="1371600"/>
+            <a:off x="731520" y="2286000"/>
             <a:ext cx="3017520" cy="457200"/>
           </a:xfrm>
           <a:prstGeom prst="rect">
@@ -4695,7 +4695,7 @@
           <a:lstStyle/>
           <a:p>
             <a:pPr algn="ctr">
-              <a:defRPr sz="2000" b="1">
+              <a:defRPr sz="2200" b="1">
                 <a:solidFill>
                   <a:srgbClr val="006DFF"/>
                 </a:solidFill>
@@ -4716,7 +4716,7 @@
         </p:nvSpPr>
         <p:spPr>
           <a:xfrm>
-            <a:off x="731520" y="1920240"/>
+            <a:off x="731520" y="2834640"/>
             <a:ext cx="3017520" cy="914400"/>
           </a:xfrm>
           <a:prstGeom prst="rect">
@@ -4731,9 +4731,9 @@
           <a:lstStyle/>
           <a:p>
             <a:pPr algn="l">
-              <a:defRPr sz="1300" b="0">
-                <a:solidFill>
-                  <a:srgbClr val="6C757D"/>
+              <a:defRPr sz="1500" b="0">
+                <a:solidFill>
+                  <a:srgbClr val="C0C8D6"/>
                 </a:solidFill>
                 <a:latin typeface="Microsoft JhengHei"/>
               </a:defRPr>
@@ -4760,8 +4760,8 @@
         </p:nvSpPr>
         <p:spPr>
           <a:xfrm>
-            <a:off x="731520" y="2926080"/>
-            <a:ext cx="3017520" cy="1188720"/>
+            <a:off x="731520" y="3840480"/>
+            <a:ext cx="3017520" cy="914400"/>
           </a:xfrm>
           <a:prstGeom prst="rect">
             <a:avLst/>
@@ -4775,7 +4775,7 @@
           <a:lstStyle/>
           <a:p>
             <a:pPr algn="l">
-              <a:defRPr sz="1300" b="1">
+              <a:defRPr sz="1500" b="1">
                 <a:solidFill>
                   <a:srgbClr val="00B4D8"/>
                 </a:solidFill>
@@ -4804,14 +4804,14 @@
         </p:nvSpPr>
         <p:spPr>
           <a:xfrm>
-            <a:off x="4297680" y="1188720"/>
-            <a:ext cx="3566160" cy="3200400"/>
+            <a:off x="4297680" y="2103120"/>
+            <a:ext cx="3566160" cy="2926080"/>
           </a:xfrm>
           <a:prstGeom prst="roundRect">
             <a:avLst/>
           </a:prstGeom>
           <a:solidFill>
-            <a:srgbClr val="242A40"/>
+            <a:srgbClr val="2B3045"/>
           </a:solidFill>
           <a:ln>
             <a:noFill/>
@@ -4847,7 +4847,7 @@
         </p:nvSpPr>
         <p:spPr>
           <a:xfrm>
-            <a:off x="4297680" y="1188720"/>
+            <a:off x="4297680" y="2103120"/>
             <a:ext cx="3566160" cy="73152"/>
           </a:xfrm>
           <a:prstGeom prst="rect">
@@ -4890,7 +4890,7 @@
         </p:nvSpPr>
         <p:spPr>
           <a:xfrm>
-            <a:off x="4572000" y="1371600"/>
+            <a:off x="4572000" y="2286000"/>
             <a:ext cx="3017520" cy="457200"/>
           </a:xfrm>
           <a:prstGeom prst="rect">
@@ -4905,7 +4905,7 @@
           <a:lstStyle/>
           <a:p>
             <a:pPr algn="ctr">
-              <a:defRPr sz="2000" b="1">
+              <a:defRPr sz="2200" b="1">
                 <a:solidFill>
                   <a:srgbClr val="00B88D"/>
                 </a:solidFill>
@@ -4926,7 +4926,7 @@
         </p:nvSpPr>
         <p:spPr>
           <a:xfrm>
-            <a:off x="4572000" y="1920240"/>
+            <a:off x="4572000" y="2834640"/>
             <a:ext cx="3017520" cy="914400"/>
           </a:xfrm>
           <a:prstGeom prst="rect">
@@ -4941,9 +4941,9 @@
           <a:lstStyle/>
           <a:p>
             <a:pPr algn="l">
-              <a:defRPr sz="1300" b="0">
-                <a:solidFill>
-                  <a:srgbClr val="6C757D"/>
+              <a:defRPr sz="1500" b="0">
+                <a:solidFill>
+                  <a:srgbClr val="C0C8D6"/>
                 </a:solidFill>
                 <a:latin typeface="Microsoft JhengHei"/>
               </a:defRPr>
@@ -4970,8 +4970,8 @@
         </p:nvSpPr>
         <p:spPr>
           <a:xfrm>
-            <a:off x="4572000" y="2926080"/>
-            <a:ext cx="3017520" cy="1188720"/>
+            <a:off x="4572000" y="3840480"/>
+            <a:ext cx="3017520" cy="914400"/>
           </a:xfrm>
           <a:prstGeom prst="rect">
             <a:avLst/>
@@ -4985,7 +4985,7 @@
           <a:lstStyle/>
           <a:p>
             <a:pPr algn="l">
-              <a:defRPr sz="1300" b="1">
+              <a:defRPr sz="1500" b="1">
                 <a:solidFill>
                   <a:srgbClr val="00B4D8"/>
                 </a:solidFill>
@@ -5014,14 +5014,14 @@
         </p:nvSpPr>
         <p:spPr>
           <a:xfrm>
-            <a:off x="8138160" y="1188720"/>
-            <a:ext cx="3566160" cy="3200400"/>
+            <a:off x="8138160" y="2103120"/>
+            <a:ext cx="3566160" cy="2926080"/>
           </a:xfrm>
           <a:prstGeom prst="roundRect">
             <a:avLst/>
           </a:prstGeom>
           <a:solidFill>
-            <a:srgbClr val="242A40"/>
+            <a:srgbClr val="2B3045"/>
           </a:solidFill>
           <a:ln>
             <a:noFill/>
@@ -5057,7 +5057,7 @@
         </p:nvSpPr>
         <p:spPr>
           <a:xfrm>
-            <a:off x="8138160" y="1188720"/>
+            <a:off x="8138160" y="2103120"/>
             <a:ext cx="3566160" cy="73152"/>
           </a:xfrm>
           <a:prstGeom prst="rect">
@@ -5100,7 +5100,7 @@
         </p:nvSpPr>
         <p:spPr>
           <a:xfrm>
-            <a:off x="8412480" y="1371600"/>
+            <a:off x="8412480" y="2286000"/>
             <a:ext cx="3017520" cy="457200"/>
           </a:xfrm>
           <a:prstGeom prst="rect">
@@ -5115,7 +5115,7 @@
           <a:lstStyle/>
           <a:p>
             <a:pPr algn="ctr">
-              <a:defRPr sz="2000" b="1">
+              <a:defRPr sz="2200" b="1">
                 <a:solidFill>
                   <a:srgbClr val="7C3AED"/>
                 </a:solidFill>
@@ -5136,7 +5136,7 @@
         </p:nvSpPr>
         <p:spPr>
           <a:xfrm>
-            <a:off x="8412480" y="1920240"/>
+            <a:off x="8412480" y="2834640"/>
             <a:ext cx="3017520" cy="914400"/>
           </a:xfrm>
           <a:prstGeom prst="rect">
@@ -5151,9 +5151,9 @@
           <a:lstStyle/>
           <a:p>
             <a:pPr algn="l">
-              <a:defRPr sz="1300" b="0">
-                <a:solidFill>
-                  <a:srgbClr val="6C757D"/>
+              <a:defRPr sz="1500" b="0">
+                <a:solidFill>
+                  <a:srgbClr val="C0C8D6"/>
                 </a:solidFill>
                 <a:latin typeface="Microsoft JhengHei"/>
               </a:defRPr>
@@ -5180,8 +5180,8 @@
         </p:nvSpPr>
         <p:spPr>
           <a:xfrm>
-            <a:off x="8412480" y="2926080"/>
-            <a:ext cx="3017520" cy="1188720"/>
+            <a:off x="8412480" y="3840480"/>
+            <a:ext cx="3017520" cy="914400"/>
           </a:xfrm>
           <a:prstGeom prst="rect">
             <a:avLst/>
@@ -5195,7 +5195,7 @@
           <a:lstStyle/>
           <a:p>
             <a:pPr algn="l">
-              <a:defRPr sz="1300" b="1">
+              <a:defRPr sz="1500" b="1">
                 <a:solidFill>
                   <a:srgbClr val="00B4D8"/>
                 </a:solidFill>
@@ -5224,14 +5224,14 @@
         </p:nvSpPr>
         <p:spPr>
           <a:xfrm>
-            <a:off x="457200" y="4663440"/>
-            <a:ext cx="11247120" cy="1371600"/>
+            <a:off x="457200" y="5303520"/>
+            <a:ext cx="11247120" cy="1188720"/>
           </a:xfrm>
           <a:prstGeom prst="roundRect">
             <a:avLst/>
           </a:prstGeom>
           <a:solidFill>
-            <a:srgbClr val="242A40"/>
+            <a:srgbClr val="2B3045"/>
           </a:solidFill>
           <a:ln>
             <a:noFill/>
@@ -5267,7 +5267,7 @@
         </p:nvSpPr>
         <p:spPr>
           <a:xfrm>
-            <a:off x="822960" y="4846320"/>
+            <a:off x="822960" y="5394960"/>
             <a:ext cx="10515600" cy="914400"/>
           </a:xfrm>
           <a:prstGeom prst="rect">
@@ -5282,9 +5282,9 @@
           <a:lstStyle/>
           <a:p>
             <a:pPr algn="l">
-              <a:defRPr sz="1400" b="0">
-                <a:solidFill>
-                  <a:srgbClr val="6C757D"/>
+              <a:defRPr sz="1500" b="0">
+                <a:solidFill>
+                  <a:srgbClr val="C0C8D6"/>
                 </a:solidFill>
                 <a:latin typeface="Microsoft JhengHei"/>
               </a:defRPr>
@@ -5545,7 +5545,7 @@
             <a:avLst/>
           </a:prstGeom>
           <a:solidFill>
-            <a:srgbClr val="242A40"/>
+            <a:srgbClr val="2B3045"/>
           </a:solidFill>
           <a:ln>
             <a:noFill/>
@@ -5598,7 +5598,7 @@
             <a:pPr algn="l">
               <a:defRPr sz="1600" b="0">
                 <a:solidFill>
-                  <a:srgbClr val="6C757D"/>
+                  <a:srgbClr val="C0C8D6"/>
                 </a:solidFill>
                 <a:latin typeface="Microsoft JhengHei"/>
               </a:defRPr>
@@ -5634,7 +5634,7 @@
             <a:pPr algn="l">
               <a:defRPr sz="1600" b="0">
                 <a:solidFill>
-                  <a:srgbClr val="6C757D"/>
+                  <a:srgbClr val="C0C8D6"/>
                 </a:solidFill>
                 <a:latin typeface="Microsoft JhengHei"/>
               </a:defRPr>
@@ -5670,7 +5670,7 @@
             <a:pPr algn="l">
               <a:defRPr sz="1600" b="0">
                 <a:solidFill>
-                  <a:srgbClr val="6C757D"/>
+                  <a:srgbClr val="C0C8D6"/>
                 </a:solidFill>
                 <a:latin typeface="Microsoft JhengHei"/>
               </a:defRPr>
@@ -5706,7 +5706,7 @@
             <a:pPr algn="l">
               <a:defRPr sz="1600" b="0">
                 <a:solidFill>
-                  <a:srgbClr val="6C757D"/>
+                  <a:srgbClr val="C0C8D6"/>
                 </a:solidFill>
                 <a:latin typeface="Microsoft JhengHei"/>
               </a:defRPr>
@@ -5742,7 +5742,7 @@
             <a:pPr algn="l">
               <a:defRPr sz="1400" b="0">
                 <a:solidFill>
-                  <a:srgbClr val="6C757D"/>
+                  <a:srgbClr val="8A94A6"/>
                 </a:solidFill>
                 <a:latin typeface="Microsoft JhengHei"/>
               </a:defRPr>
@@ -5778,7 +5778,7 @@
             <a:pPr algn="l">
               <a:defRPr sz="1400" b="0">
                 <a:solidFill>
-                  <a:srgbClr val="6C757D"/>
+                  <a:srgbClr val="8A94A6"/>
                 </a:solidFill>
                 <a:latin typeface="Microsoft JhengHei"/>
               </a:defRPr>
@@ -5958,8 +5958,8 @@
         </p:nvSpPr>
         <p:spPr>
           <a:xfrm>
-            <a:off x="914400" y="1828800"/>
-            <a:ext cx="10058400" cy="1371600"/>
+            <a:off x="914400" y="457200"/>
+            <a:ext cx="10058400" cy="1097280"/>
           </a:xfrm>
           <a:prstGeom prst="rect">
             <a:avLst/>
@@ -5994,8 +5994,8 @@
         </p:nvSpPr>
         <p:spPr>
           <a:xfrm>
-            <a:off x="914400" y="3200400"/>
-            <a:ext cx="10058400" cy="914400"/>
+            <a:off x="914400" y="1371600"/>
+            <a:ext cx="10058400" cy="731520"/>
           </a:xfrm>
           <a:prstGeom prst="rect">
             <a:avLst/>
@@ -6009,7 +6009,7 @@
           <a:lstStyle/>
           <a:p>
             <a:pPr algn="l">
-              <a:defRPr sz="2000" b="0">
+              <a:defRPr sz="2400" b="0">
                 <a:solidFill>
                   <a:srgbClr val="00B4D8"/>
                 </a:solidFill>
@@ -6030,8 +6030,8 @@
         </p:nvSpPr>
         <p:spPr>
           <a:xfrm>
-            <a:off x="731520" y="914400"/>
-            <a:ext cx="5303520" cy="1097280"/>
+            <a:off x="731520" y="2103120"/>
+            <a:ext cx="5303520" cy="1005840"/>
           </a:xfrm>
           <a:prstGeom prst="roundRect">
             <a:avLst/>
@@ -6073,7 +6073,7 @@
         </p:nvSpPr>
         <p:spPr>
           <a:xfrm>
-            <a:off x="1005840" y="1005840"/>
+            <a:off x="1005840" y="2148840"/>
             <a:ext cx="731520" cy="914400"/>
           </a:xfrm>
           <a:prstGeom prst="rect">
@@ -6109,8 +6109,8 @@
         </p:nvSpPr>
         <p:spPr>
           <a:xfrm>
-            <a:off x="1737360" y="960120"/>
-            <a:ext cx="3931920" cy="548640"/>
+            <a:off x="1737360" y="2148840"/>
+            <a:ext cx="3931920" cy="457200"/>
           </a:xfrm>
           <a:prstGeom prst="rect">
             <a:avLst/>
@@ -6124,7 +6124,7 @@
           <a:lstStyle/>
           <a:p>
             <a:pPr algn="l">
-              <a:defRPr sz="1800" b="1">
+              <a:defRPr sz="2000" b="1">
                 <a:solidFill>
                   <a:srgbClr val="FFFFFF"/>
                 </a:solidFill>
@@ -6145,7 +6145,7 @@
         </p:nvSpPr>
         <p:spPr>
           <a:xfrm>
-            <a:off x="1737360" y="1463040"/>
+            <a:off x="1737360" y="2606040"/>
             <a:ext cx="3931920" cy="457200"/>
           </a:xfrm>
           <a:prstGeom prst="rect">
@@ -6160,9 +6160,9 @@
           <a:lstStyle/>
           <a:p>
             <a:pPr algn="l">
-              <a:defRPr sz="1300" b="0">
-                <a:solidFill>
-                  <a:srgbClr val="6C757D"/>
+              <a:defRPr sz="1500" b="0">
+                <a:solidFill>
+                  <a:srgbClr val="8A94A6"/>
                 </a:solidFill>
                 <a:latin typeface="Microsoft JhengHei"/>
               </a:defRPr>
@@ -6181,8 +6181,8 @@
         </p:nvSpPr>
         <p:spPr>
           <a:xfrm>
-            <a:off x="6400800" y="914400"/>
-            <a:ext cx="5303520" cy="1097280"/>
+            <a:off x="6400800" y="2103120"/>
+            <a:ext cx="5303520" cy="1005840"/>
           </a:xfrm>
           <a:prstGeom prst="roundRect">
             <a:avLst/>
@@ -6224,7 +6224,7 @@
         </p:nvSpPr>
         <p:spPr>
           <a:xfrm>
-            <a:off x="6675120" y="1005840"/>
+            <a:off x="6675120" y="2148840"/>
             <a:ext cx="731520" cy="914400"/>
           </a:xfrm>
           <a:prstGeom prst="rect">
@@ -6260,8 +6260,8 @@
         </p:nvSpPr>
         <p:spPr>
           <a:xfrm>
-            <a:off x="7406640" y="960120"/>
-            <a:ext cx="3931920" cy="548640"/>
+            <a:off x="7406640" y="2148840"/>
+            <a:ext cx="3931920" cy="457200"/>
           </a:xfrm>
           <a:prstGeom prst="rect">
             <a:avLst/>
@@ -6275,7 +6275,7 @@
           <a:lstStyle/>
           <a:p>
             <a:pPr algn="l">
-              <a:defRPr sz="1800" b="1">
+              <a:defRPr sz="2000" b="1">
                 <a:solidFill>
                   <a:srgbClr val="FFFFFF"/>
                 </a:solidFill>
@@ -6296,7 +6296,7 @@
         </p:nvSpPr>
         <p:spPr>
           <a:xfrm>
-            <a:off x="7406640" y="1463040"/>
+            <a:off x="7406640" y="2606040"/>
             <a:ext cx="3931920" cy="457200"/>
           </a:xfrm>
           <a:prstGeom prst="rect">
@@ -6311,9 +6311,9 @@
           <a:lstStyle/>
           <a:p>
             <a:pPr algn="l">
-              <a:defRPr sz="1300" b="0">
-                <a:solidFill>
-                  <a:srgbClr val="6C757D"/>
+              <a:defRPr sz="1500" b="0">
+                <a:solidFill>
+                  <a:srgbClr val="8A94A6"/>
                 </a:solidFill>
                 <a:latin typeface="Microsoft JhengHei"/>
               </a:defRPr>
@@ -6332,14 +6332,14 @@
         </p:nvSpPr>
         <p:spPr>
           <a:xfrm>
-            <a:off x="731520" y="2286000"/>
-            <a:ext cx="5303520" cy="1097280"/>
+            <a:off x="731520" y="3291839"/>
+            <a:ext cx="5303520" cy="1005840"/>
           </a:xfrm>
           <a:prstGeom prst="roundRect">
             <a:avLst/>
           </a:prstGeom>
           <a:solidFill>
-            <a:srgbClr val="242A40"/>
+            <a:srgbClr val="2B3045"/>
           </a:solidFill>
           <a:ln>
             <a:noFill/>
@@ -6375,7 +6375,7 @@
         </p:nvSpPr>
         <p:spPr>
           <a:xfrm>
-            <a:off x="1005840" y="2377440"/>
+            <a:off x="1005840" y="3337559"/>
             <a:ext cx="731520" cy="914400"/>
           </a:xfrm>
           <a:prstGeom prst="rect">
@@ -6411,8 +6411,8 @@
         </p:nvSpPr>
         <p:spPr>
           <a:xfrm>
-            <a:off x="1737360" y="2331720"/>
-            <a:ext cx="3931920" cy="548640"/>
+            <a:off x="1737360" y="3337559"/>
+            <a:ext cx="3931920" cy="457200"/>
           </a:xfrm>
           <a:prstGeom prst="rect">
             <a:avLst/>
@@ -6426,7 +6426,7 @@
           <a:lstStyle/>
           <a:p>
             <a:pPr algn="l">
-              <a:defRPr sz="1800" b="1">
+              <a:defRPr sz="2000" b="1">
                 <a:solidFill>
                   <a:srgbClr val="FFFFFF"/>
                 </a:solidFill>
@@ -6447,7 +6447,7 @@
         </p:nvSpPr>
         <p:spPr>
           <a:xfrm>
-            <a:off x="1737360" y="2834640"/>
+            <a:off x="1737360" y="3794759"/>
             <a:ext cx="3931920" cy="457200"/>
           </a:xfrm>
           <a:prstGeom prst="rect">
@@ -6462,9 +6462,9 @@
           <a:lstStyle/>
           <a:p>
             <a:pPr algn="l">
-              <a:defRPr sz="1300" b="0">
-                <a:solidFill>
-                  <a:srgbClr val="6C757D"/>
+              <a:defRPr sz="1500" b="0">
+                <a:solidFill>
+                  <a:srgbClr val="8A94A6"/>
                 </a:solidFill>
                 <a:latin typeface="Microsoft JhengHei"/>
               </a:defRPr>
@@ -6483,14 +6483,14 @@
         </p:nvSpPr>
         <p:spPr>
           <a:xfrm>
-            <a:off x="6400800" y="2286000"/>
-            <a:ext cx="5303520" cy="1097280"/>
+            <a:off x="6400800" y="3291839"/>
+            <a:ext cx="5303520" cy="1005840"/>
           </a:xfrm>
           <a:prstGeom prst="roundRect">
             <a:avLst/>
           </a:prstGeom>
           <a:solidFill>
-            <a:srgbClr val="242A40"/>
+            <a:srgbClr val="2B3045"/>
           </a:solidFill>
           <a:ln>
             <a:noFill/>
@@ -6526,7 +6526,7 @@
         </p:nvSpPr>
         <p:spPr>
           <a:xfrm>
-            <a:off x="6675120" y="2377440"/>
+            <a:off x="6675120" y="3337559"/>
             <a:ext cx="731520" cy="914400"/>
           </a:xfrm>
           <a:prstGeom prst="rect">
@@ -6562,8 +6562,8 @@
         </p:nvSpPr>
         <p:spPr>
           <a:xfrm>
-            <a:off x="7406640" y="2331720"/>
-            <a:ext cx="3931920" cy="548640"/>
+            <a:off x="7406640" y="3337559"/>
+            <a:ext cx="3931920" cy="457200"/>
           </a:xfrm>
           <a:prstGeom prst="rect">
             <a:avLst/>
@@ -6577,7 +6577,7 @@
           <a:lstStyle/>
           <a:p>
             <a:pPr algn="l">
-              <a:defRPr sz="1800" b="1">
+              <a:defRPr sz="2000" b="1">
                 <a:solidFill>
                   <a:srgbClr val="FFFFFF"/>
                 </a:solidFill>
@@ -6598,7 +6598,7 @@
         </p:nvSpPr>
         <p:spPr>
           <a:xfrm>
-            <a:off x="7406640" y="2834640"/>
+            <a:off x="7406640" y="3794759"/>
             <a:ext cx="3931920" cy="457200"/>
           </a:xfrm>
           <a:prstGeom prst="rect">
@@ -6613,9 +6613,9 @@
           <a:lstStyle/>
           <a:p>
             <a:pPr algn="l">
-              <a:defRPr sz="1300" b="0">
-                <a:solidFill>
-                  <a:srgbClr val="6C757D"/>
+              <a:defRPr sz="1500" b="0">
+                <a:solidFill>
+                  <a:srgbClr val="8A94A6"/>
                 </a:solidFill>
                 <a:latin typeface="Microsoft JhengHei"/>
               </a:defRPr>
@@ -6634,14 +6634,14 @@
         </p:nvSpPr>
         <p:spPr>
           <a:xfrm>
-            <a:off x="731520" y="3657600"/>
-            <a:ext cx="5303520" cy="1097280"/>
+            <a:off x="731520" y="4480560"/>
+            <a:ext cx="5303520" cy="1005840"/>
           </a:xfrm>
           <a:prstGeom prst="roundRect">
             <a:avLst/>
           </a:prstGeom>
           <a:solidFill>
-            <a:srgbClr val="242A40"/>
+            <a:srgbClr val="2B3045"/>
           </a:solidFill>
           <a:ln>
             <a:noFill/>
@@ -6677,7 +6677,7 @@
         </p:nvSpPr>
         <p:spPr>
           <a:xfrm>
-            <a:off x="1005840" y="3749040"/>
+            <a:off x="1005840" y="4526280"/>
             <a:ext cx="731520" cy="914400"/>
           </a:xfrm>
           <a:prstGeom prst="rect">
@@ -6713,8 +6713,8 @@
         </p:nvSpPr>
         <p:spPr>
           <a:xfrm>
-            <a:off x="1737360" y="3703320"/>
-            <a:ext cx="3931920" cy="548640"/>
+            <a:off x="1737360" y="4526280"/>
+            <a:ext cx="3931920" cy="457200"/>
           </a:xfrm>
           <a:prstGeom prst="rect">
             <a:avLst/>
@@ -6728,7 +6728,7 @@
           <a:lstStyle/>
           <a:p>
             <a:pPr algn="l">
-              <a:defRPr sz="1800" b="1">
+              <a:defRPr sz="2000" b="1">
                 <a:solidFill>
                   <a:srgbClr val="FFFFFF"/>
                 </a:solidFill>
@@ -6749,7 +6749,7 @@
         </p:nvSpPr>
         <p:spPr>
           <a:xfrm>
-            <a:off x="1737360" y="4206240"/>
+            <a:off x="1737360" y="4983480"/>
             <a:ext cx="3931920" cy="457200"/>
           </a:xfrm>
           <a:prstGeom prst="rect">
@@ -6764,9 +6764,9 @@
           <a:lstStyle/>
           <a:p>
             <a:pPr algn="l">
-              <a:defRPr sz="1300" b="0">
-                <a:solidFill>
-                  <a:srgbClr val="6C757D"/>
+              <a:defRPr sz="1500" b="0">
+                <a:solidFill>
+                  <a:srgbClr val="8A94A6"/>
                 </a:solidFill>
                 <a:latin typeface="Microsoft JhengHei"/>
               </a:defRPr>
@@ -6785,14 +6785,14 @@
         </p:nvSpPr>
         <p:spPr>
           <a:xfrm>
-            <a:off x="6400800" y="3657600"/>
-            <a:ext cx="5303520" cy="1097280"/>
+            <a:off x="6400800" y="4480560"/>
+            <a:ext cx="5303520" cy="1005840"/>
           </a:xfrm>
           <a:prstGeom prst="roundRect">
             <a:avLst/>
           </a:prstGeom>
           <a:solidFill>
-            <a:srgbClr val="242A40"/>
+            <a:srgbClr val="2B3045"/>
           </a:solidFill>
           <a:ln>
             <a:noFill/>
@@ -6828,7 +6828,7 @@
         </p:nvSpPr>
         <p:spPr>
           <a:xfrm>
-            <a:off x="6675120" y="3749040"/>
+            <a:off x="6675120" y="4526280"/>
             <a:ext cx="731520" cy="914400"/>
           </a:xfrm>
           <a:prstGeom prst="rect">
@@ -6864,8 +6864,8 @@
         </p:nvSpPr>
         <p:spPr>
           <a:xfrm>
-            <a:off x="7406640" y="3703320"/>
-            <a:ext cx="3931920" cy="548640"/>
+            <a:off x="7406640" y="4526280"/>
+            <a:ext cx="3931920" cy="457200"/>
           </a:xfrm>
           <a:prstGeom prst="rect">
             <a:avLst/>
@@ -6879,7 +6879,7 @@
           <a:lstStyle/>
           <a:p>
             <a:pPr algn="l">
-              <a:defRPr sz="1800" b="1">
+              <a:defRPr sz="2000" b="1">
                 <a:solidFill>
                   <a:srgbClr val="FFFFFF"/>
                 </a:solidFill>
@@ -6900,7 +6900,7 @@
         </p:nvSpPr>
         <p:spPr>
           <a:xfrm>
-            <a:off x="7406640" y="4206240"/>
+            <a:off x="7406640" y="4983480"/>
             <a:ext cx="3931920" cy="457200"/>
           </a:xfrm>
           <a:prstGeom prst="rect">
@@ -6915,9 +6915,9 @@
           <a:lstStyle/>
           <a:p>
             <a:pPr algn="l">
-              <a:defRPr sz="1300" b="0">
-                <a:solidFill>
-                  <a:srgbClr val="6C757D"/>
+              <a:defRPr sz="1500" b="0">
+                <a:solidFill>
+                  <a:srgbClr val="8A94A6"/>
                 </a:solidFill>
                 <a:latin typeface="Microsoft JhengHei"/>
               </a:defRPr>
@@ -6936,14 +6936,14 @@
         </p:nvSpPr>
         <p:spPr>
           <a:xfrm>
-            <a:off x="731520" y="5029200"/>
-            <a:ext cx="5303520" cy="1097280"/>
+            <a:off x="731520" y="5669280"/>
+            <a:ext cx="5303520" cy="1005840"/>
           </a:xfrm>
           <a:prstGeom prst="roundRect">
             <a:avLst/>
           </a:prstGeom>
           <a:solidFill>
-            <a:srgbClr val="242A40"/>
+            <a:srgbClr val="2B3045"/>
           </a:solidFill>
           <a:ln>
             <a:noFill/>
@@ -6979,7 +6979,7 @@
         </p:nvSpPr>
         <p:spPr>
           <a:xfrm>
-            <a:off x="1005840" y="5120640"/>
+            <a:off x="1005840" y="5715000"/>
             <a:ext cx="731520" cy="914400"/>
           </a:xfrm>
           <a:prstGeom prst="rect">
@@ -7015,8 +7015,8 @@
         </p:nvSpPr>
         <p:spPr>
           <a:xfrm>
-            <a:off x="1737360" y="5074920"/>
-            <a:ext cx="3931920" cy="548640"/>
+            <a:off x="1737360" y="5715000"/>
+            <a:ext cx="3931920" cy="457200"/>
           </a:xfrm>
           <a:prstGeom prst="rect">
             <a:avLst/>
@@ -7030,7 +7030,7 @@
           <a:lstStyle/>
           <a:p>
             <a:pPr algn="l">
-              <a:defRPr sz="1800" b="1">
+              <a:defRPr sz="2000" b="1">
                 <a:solidFill>
                   <a:srgbClr val="FFFFFF"/>
                 </a:solidFill>
@@ -7051,7 +7051,7 @@
         </p:nvSpPr>
         <p:spPr>
           <a:xfrm>
-            <a:off x="1737360" y="5577840"/>
+            <a:off x="1737360" y="6172200"/>
             <a:ext cx="3931920" cy="457200"/>
           </a:xfrm>
           <a:prstGeom prst="rect">
@@ -7066,9 +7066,9 @@
           <a:lstStyle/>
           <a:p>
             <a:pPr algn="l">
-              <a:defRPr sz="1300" b="0">
-                <a:solidFill>
-                  <a:srgbClr val="6C757D"/>
+              <a:defRPr sz="1500" b="0">
+                <a:solidFill>
+                  <a:srgbClr val="8A94A6"/>
                 </a:solidFill>
                 <a:latin typeface="Microsoft JhengHei"/>
               </a:defRPr>
@@ -7087,14 +7087,14 @@
         </p:nvSpPr>
         <p:spPr>
           <a:xfrm>
-            <a:off x="6400800" y="5029200"/>
-            <a:ext cx="5303520" cy="1097280"/>
+            <a:off x="6400800" y="5669280"/>
+            <a:ext cx="5303520" cy="1005840"/>
           </a:xfrm>
           <a:prstGeom prst="roundRect">
             <a:avLst/>
           </a:prstGeom>
           <a:solidFill>
-            <a:srgbClr val="242A40"/>
+            <a:srgbClr val="2B3045"/>
           </a:solidFill>
           <a:ln>
             <a:noFill/>
@@ -7130,7 +7130,7 @@
         </p:nvSpPr>
         <p:spPr>
           <a:xfrm>
-            <a:off x="6675120" y="5120640"/>
+            <a:off x="6675120" y="5715000"/>
             <a:ext cx="731520" cy="914400"/>
           </a:xfrm>
           <a:prstGeom prst="rect">
@@ -7166,8 +7166,8 @@
         </p:nvSpPr>
         <p:spPr>
           <a:xfrm>
-            <a:off x="7406640" y="5074920"/>
-            <a:ext cx="3931920" cy="548640"/>
+            <a:off x="7406640" y="5715000"/>
+            <a:ext cx="3931920" cy="457200"/>
           </a:xfrm>
           <a:prstGeom prst="rect">
             <a:avLst/>
@@ -7181,7 +7181,7 @@
           <a:lstStyle/>
           <a:p>
             <a:pPr algn="l">
-              <a:defRPr sz="1800" b="1">
+              <a:defRPr sz="2000" b="1">
                 <a:solidFill>
                   <a:srgbClr val="FFFFFF"/>
                 </a:solidFill>
@@ -7202,7 +7202,7 @@
         </p:nvSpPr>
         <p:spPr>
           <a:xfrm>
-            <a:off x="7406640" y="5577840"/>
+            <a:off x="7406640" y="6172200"/>
             <a:ext cx="3931920" cy="457200"/>
           </a:xfrm>
           <a:prstGeom prst="rect">
@@ -7217,9 +7217,9 @@
           <a:lstStyle/>
           <a:p>
             <a:pPr algn="l">
-              <a:defRPr sz="1300" b="0">
-                <a:solidFill>
-                  <a:srgbClr val="6C757D"/>
+              <a:defRPr sz="1500" b="0">
+                <a:solidFill>
+                  <a:srgbClr val="8A94A6"/>
                 </a:solidFill>
                 <a:latin typeface="Microsoft JhengHei"/>
               </a:defRPr>
@@ -7307,8 +7307,8 @@
         </p:nvSpPr>
         <p:spPr>
           <a:xfrm>
-            <a:off x="914400" y="1828800"/>
-            <a:ext cx="10058400" cy="1371600"/>
+            <a:off x="914400" y="457200"/>
+            <a:ext cx="10058400" cy="1097280"/>
           </a:xfrm>
           <a:prstGeom prst="rect">
             <a:avLst/>
@@ -7343,8 +7343,8 @@
         </p:nvSpPr>
         <p:spPr>
           <a:xfrm>
-            <a:off x="914400" y="3200400"/>
-            <a:ext cx="10058400" cy="914400"/>
+            <a:off x="914400" y="1371600"/>
+            <a:ext cx="10058400" cy="731520"/>
           </a:xfrm>
           <a:prstGeom prst="rect">
             <a:avLst/>
@@ -7358,7 +7358,7 @@
           <a:lstStyle/>
           <a:p>
             <a:pPr algn="l">
-              <a:defRPr sz="2000" b="0">
+              <a:defRPr sz="2400" b="0">
                 <a:solidFill>
                   <a:srgbClr val="00B4D8"/>
                 </a:solidFill>
@@ -7379,14 +7379,14 @@
         </p:nvSpPr>
         <p:spPr>
           <a:xfrm>
-            <a:off x="548640" y="1188720"/>
-            <a:ext cx="2697480" cy="2743200"/>
+            <a:off x="548640" y="2103120"/>
+            <a:ext cx="2697480" cy="2560320"/>
           </a:xfrm>
           <a:prstGeom prst="roundRect">
             <a:avLst/>
           </a:prstGeom>
           <a:solidFill>
-            <a:srgbClr val="242A40"/>
+            <a:srgbClr val="2B3045"/>
           </a:solidFill>
           <a:ln>
             <a:noFill/>
@@ -7422,7 +7422,7 @@
         </p:nvSpPr>
         <p:spPr>
           <a:xfrm>
-            <a:off x="548640" y="1188720"/>
+            <a:off x="548640" y="2103120"/>
             <a:ext cx="2697480" cy="73152"/>
           </a:xfrm>
           <a:prstGeom prst="rect">
@@ -7465,7 +7465,7 @@
         </p:nvSpPr>
         <p:spPr>
           <a:xfrm>
-            <a:off x="822960" y="1554480"/>
+            <a:off x="822960" y="2468880"/>
             <a:ext cx="2148840" cy="457200"/>
           </a:xfrm>
           <a:prstGeom prst="rect">
@@ -7480,7 +7480,7 @@
           <a:lstStyle/>
           <a:p>
             <a:pPr algn="l">
-              <a:defRPr sz="2200" b="1">
+              <a:defRPr sz="2400" b="1">
                 <a:solidFill>
                   <a:srgbClr val="006DFF"/>
                 </a:solidFill>
@@ -7501,8 +7501,8 @@
         </p:nvSpPr>
         <p:spPr>
           <a:xfrm>
-            <a:off x="822960" y="2194560"/>
-            <a:ext cx="2148840" cy="1463040"/>
+            <a:off x="822960" y="3108960"/>
+            <a:ext cx="2148840" cy="1371600"/>
           </a:xfrm>
           <a:prstGeom prst="rect">
             <a:avLst/>
@@ -7516,9 +7516,9 @@
           <a:lstStyle/>
           <a:p>
             <a:pPr algn="l">
-              <a:defRPr sz="1400" b="0">
-                <a:solidFill>
-                  <a:srgbClr val="6C757D"/>
+              <a:defRPr sz="1700" b="0">
+                <a:solidFill>
+                  <a:srgbClr val="C0C8D6"/>
                 </a:solidFill>
                 <a:latin typeface="Microsoft JhengHei"/>
               </a:defRPr>
@@ -7541,14 +7541,14 @@
         </p:nvSpPr>
         <p:spPr>
           <a:xfrm>
-            <a:off x="3429000" y="1188720"/>
-            <a:ext cx="2697480" cy="2743200"/>
+            <a:off x="3429000" y="2103120"/>
+            <a:ext cx="2697480" cy="2560320"/>
           </a:xfrm>
           <a:prstGeom prst="roundRect">
             <a:avLst/>
           </a:prstGeom>
           <a:solidFill>
-            <a:srgbClr val="242A40"/>
+            <a:srgbClr val="2B3045"/>
           </a:solidFill>
           <a:ln>
             <a:noFill/>
@@ -7584,7 +7584,7 @@
         </p:nvSpPr>
         <p:spPr>
           <a:xfrm>
-            <a:off x="3429000" y="1188720"/>
+            <a:off x="3429000" y="2103120"/>
             <a:ext cx="2697480" cy="73152"/>
           </a:xfrm>
           <a:prstGeom prst="rect">
@@ -7627,7 +7627,7 @@
         </p:nvSpPr>
         <p:spPr>
           <a:xfrm>
-            <a:off x="3703320" y="1554480"/>
+            <a:off x="3703320" y="2468880"/>
             <a:ext cx="2148840" cy="457200"/>
           </a:xfrm>
           <a:prstGeom prst="rect">
@@ -7642,7 +7642,7 @@
           <a:lstStyle/>
           <a:p>
             <a:pPr algn="l">
-              <a:defRPr sz="2200" b="1">
+              <a:defRPr sz="2400" b="1">
                 <a:solidFill>
                   <a:srgbClr val="FF6B35"/>
                 </a:solidFill>
@@ -7663,8 +7663,8 @@
         </p:nvSpPr>
         <p:spPr>
           <a:xfrm>
-            <a:off x="3703320" y="2194560"/>
-            <a:ext cx="2148840" cy="1463040"/>
+            <a:off x="3703320" y="3108960"/>
+            <a:ext cx="2148840" cy="1371600"/>
           </a:xfrm>
           <a:prstGeom prst="rect">
             <a:avLst/>
@@ -7678,9 +7678,9 @@
           <a:lstStyle/>
           <a:p>
             <a:pPr algn="l">
-              <a:defRPr sz="1400" b="0">
-                <a:solidFill>
-                  <a:srgbClr val="6C757D"/>
+              <a:defRPr sz="1700" b="0">
+                <a:solidFill>
+                  <a:srgbClr val="C0C8D6"/>
                 </a:solidFill>
                 <a:latin typeface="Microsoft JhengHei"/>
               </a:defRPr>
@@ -7703,14 +7703,14 @@
         </p:nvSpPr>
         <p:spPr>
           <a:xfrm>
-            <a:off x="6309359" y="1188720"/>
-            <a:ext cx="2697480" cy="2743200"/>
+            <a:off x="6309359" y="2103120"/>
+            <a:ext cx="2697480" cy="2560320"/>
           </a:xfrm>
           <a:prstGeom prst="roundRect">
             <a:avLst/>
           </a:prstGeom>
           <a:solidFill>
-            <a:srgbClr val="242A40"/>
+            <a:srgbClr val="2B3045"/>
           </a:solidFill>
           <a:ln>
             <a:noFill/>
@@ -7746,7 +7746,7 @@
         </p:nvSpPr>
         <p:spPr>
           <a:xfrm>
-            <a:off x="6309359" y="1188720"/>
+            <a:off x="6309359" y="2103120"/>
             <a:ext cx="2697480" cy="73152"/>
           </a:xfrm>
           <a:prstGeom prst="rect">
@@ -7789,7 +7789,7 @@
         </p:nvSpPr>
         <p:spPr>
           <a:xfrm>
-            <a:off x="6583679" y="1554480"/>
+            <a:off x="6583679" y="2468880"/>
             <a:ext cx="2148840" cy="457200"/>
           </a:xfrm>
           <a:prstGeom prst="rect">
@@ -7804,7 +7804,7 @@
           <a:lstStyle/>
           <a:p>
             <a:pPr algn="l">
-              <a:defRPr sz="2200" b="1">
+              <a:defRPr sz="2400" b="1">
                 <a:solidFill>
                   <a:srgbClr val="7C3AED"/>
                 </a:solidFill>
@@ -7825,8 +7825,8 @@
         </p:nvSpPr>
         <p:spPr>
           <a:xfrm>
-            <a:off x="6583679" y="2194560"/>
-            <a:ext cx="2148840" cy="1463040"/>
+            <a:off x="6583679" y="3108960"/>
+            <a:ext cx="2148840" cy="1371600"/>
           </a:xfrm>
           <a:prstGeom prst="rect">
             <a:avLst/>
@@ -7840,9 +7840,9 @@
           <a:lstStyle/>
           <a:p>
             <a:pPr algn="l">
-              <a:defRPr sz="1400" b="0">
-                <a:solidFill>
-                  <a:srgbClr val="6C757D"/>
+              <a:defRPr sz="1700" b="0">
+                <a:solidFill>
+                  <a:srgbClr val="C0C8D6"/>
                 </a:solidFill>
                 <a:latin typeface="Microsoft JhengHei"/>
               </a:defRPr>
@@ -7865,14 +7865,14 @@
         </p:nvSpPr>
         <p:spPr>
           <a:xfrm>
-            <a:off x="9189719" y="1188720"/>
-            <a:ext cx="2697480" cy="2743200"/>
+            <a:off x="9189719" y="2103120"/>
+            <a:ext cx="2697480" cy="2560320"/>
           </a:xfrm>
           <a:prstGeom prst="roundRect">
             <a:avLst/>
           </a:prstGeom>
           <a:solidFill>
-            <a:srgbClr val="242A40"/>
+            <a:srgbClr val="2B3045"/>
           </a:solidFill>
           <a:ln>
             <a:noFill/>
@@ -7908,7 +7908,7 @@
         </p:nvSpPr>
         <p:spPr>
           <a:xfrm>
-            <a:off x="9189719" y="1188720"/>
+            <a:off x="9189719" y="2103120"/>
             <a:ext cx="2697480" cy="73152"/>
           </a:xfrm>
           <a:prstGeom prst="rect">
@@ -7951,7 +7951,7 @@
         </p:nvSpPr>
         <p:spPr>
           <a:xfrm>
-            <a:off x="9464039" y="1554480"/>
+            <a:off x="9464039" y="2468880"/>
             <a:ext cx="2148840" cy="457200"/>
           </a:xfrm>
           <a:prstGeom prst="rect">
@@ -7966,7 +7966,7 @@
           <a:lstStyle/>
           <a:p>
             <a:pPr algn="l">
-              <a:defRPr sz="2200" b="1">
+              <a:defRPr sz="2400" b="1">
                 <a:solidFill>
                   <a:srgbClr val="00B88D"/>
                 </a:solidFill>
@@ -7987,8 +7987,8 @@
         </p:nvSpPr>
         <p:spPr>
           <a:xfrm>
-            <a:off x="9464039" y="2194560"/>
-            <a:ext cx="2148840" cy="1463040"/>
+            <a:off x="9464039" y="3108960"/>
+            <a:ext cx="2148840" cy="1371600"/>
           </a:xfrm>
           <a:prstGeom prst="rect">
             <a:avLst/>
@@ -8002,9 +8002,9 @@
           <a:lstStyle/>
           <a:p>
             <a:pPr algn="l">
-              <a:defRPr sz="1400" b="0">
-                <a:solidFill>
-                  <a:srgbClr val="6C757D"/>
+              <a:defRPr sz="1700" b="0">
+                <a:solidFill>
+                  <a:srgbClr val="C0C8D6"/>
                 </a:solidFill>
                 <a:latin typeface="Microsoft JhengHei"/>
               </a:defRPr>
@@ -8027,14 +8027,14 @@
         </p:nvSpPr>
         <p:spPr>
           <a:xfrm>
-            <a:off x="548640" y="4206240"/>
-            <a:ext cx="11064240" cy="1828800"/>
+            <a:off x="548640" y="4937760"/>
+            <a:ext cx="11064240" cy="1463040"/>
           </a:xfrm>
           <a:prstGeom prst="roundRect">
             <a:avLst/>
           </a:prstGeom>
           <a:solidFill>
-            <a:srgbClr val="242A40"/>
+            <a:srgbClr val="2B3045"/>
           </a:solidFill>
           <a:ln>
             <a:noFill/>
@@ -8070,7 +8070,7 @@
         </p:nvSpPr>
         <p:spPr>
           <a:xfrm>
-            <a:off x="914400" y="4389120"/>
+            <a:off x="914400" y="5029200"/>
             <a:ext cx="10332720" cy="457200"/>
           </a:xfrm>
           <a:prstGeom prst="rect">
@@ -8085,7 +8085,7 @@
           <a:lstStyle/>
           <a:p>
             <a:pPr algn="l">
-              <a:defRPr sz="1800" b="1">
+              <a:defRPr sz="2000" b="1">
                 <a:solidFill>
                   <a:srgbClr val="00B4D8"/>
                 </a:solidFill>
@@ -8106,8 +8106,8 @@
         </p:nvSpPr>
         <p:spPr>
           <a:xfrm>
-            <a:off x="914400" y="4937760"/>
-            <a:ext cx="10332720" cy="914400"/>
+            <a:off x="914400" y="5577840"/>
+            <a:ext cx="10332720" cy="640080"/>
           </a:xfrm>
           <a:prstGeom prst="rect">
             <a:avLst/>
@@ -8121,9 +8121,9 @@
           <a:lstStyle/>
           <a:p>
             <a:pPr algn="l">
-              <a:defRPr sz="1400" b="0">
-                <a:solidFill>
-                  <a:srgbClr val="6C757D"/>
+              <a:defRPr sz="1600" b="0">
+                <a:solidFill>
+                  <a:srgbClr val="C0C8D6"/>
                 </a:solidFill>
                 <a:latin typeface="Microsoft JhengHei"/>
               </a:defRPr>
@@ -8211,8 +8211,8 @@
         </p:nvSpPr>
         <p:spPr>
           <a:xfrm>
-            <a:off x="914400" y="1828800"/>
-            <a:ext cx="10058400" cy="1371600"/>
+            <a:off x="914400" y="457200"/>
+            <a:ext cx="10058400" cy="1097280"/>
           </a:xfrm>
           <a:prstGeom prst="rect">
             <a:avLst/>
@@ -8247,8 +8247,8 @@
         </p:nvSpPr>
         <p:spPr>
           <a:xfrm>
-            <a:off x="914400" y="3200400"/>
-            <a:ext cx="10058400" cy="914400"/>
+            <a:off x="914400" y="1371600"/>
+            <a:ext cx="10058400" cy="731520"/>
           </a:xfrm>
           <a:prstGeom prst="rect">
             <a:avLst/>
@@ -8262,7 +8262,7 @@
           <a:lstStyle/>
           <a:p>
             <a:pPr algn="l">
-              <a:defRPr sz="2000" b="0">
+              <a:defRPr sz="2400" b="0">
                 <a:solidFill>
                   <a:srgbClr val="00B4D8"/>
                 </a:solidFill>
@@ -8283,14 +8283,14 @@
         </p:nvSpPr>
         <p:spPr>
           <a:xfrm>
-            <a:off x="548640" y="1188720"/>
-            <a:ext cx="2697480" cy="2560320"/>
+            <a:off x="548640" y="2103120"/>
+            <a:ext cx="2697480" cy="2286000"/>
           </a:xfrm>
           <a:prstGeom prst="roundRect">
             <a:avLst/>
           </a:prstGeom>
           <a:solidFill>
-            <a:srgbClr val="242A40"/>
+            <a:srgbClr val="2B3045"/>
           </a:solidFill>
           <a:ln>
             <a:noFill/>
@@ -8326,7 +8326,7 @@
         </p:nvSpPr>
         <p:spPr>
           <a:xfrm>
-            <a:off x="548640" y="1188720"/>
+            <a:off x="548640" y="2103120"/>
             <a:ext cx="2697480" cy="73152"/>
           </a:xfrm>
           <a:prstGeom prst="rect">
@@ -8369,7 +8369,7 @@
         </p:nvSpPr>
         <p:spPr>
           <a:xfrm>
-            <a:off x="822960" y="1463040"/>
+            <a:off x="822960" y="2377440"/>
             <a:ext cx="2148840" cy="548640"/>
           </a:xfrm>
           <a:prstGeom prst="rect">
@@ -8384,7 +8384,7 @@
           <a:lstStyle/>
           <a:p>
             <a:pPr algn="l">
-              <a:defRPr sz="1800" b="1">
+              <a:defRPr sz="2000" b="1">
                 <a:solidFill>
                   <a:srgbClr val="006DFF"/>
                 </a:solidFill>
@@ -8405,8 +8405,8 @@
         </p:nvSpPr>
         <p:spPr>
           <a:xfrm>
-            <a:off x="822960" y="2194560"/>
-            <a:ext cx="2148840" cy="1371600"/>
+            <a:off x="822960" y="3017520"/>
+            <a:ext cx="2148840" cy="1280160"/>
           </a:xfrm>
           <a:prstGeom prst="rect">
             <a:avLst/>
@@ -8420,9 +8420,9 @@
           <a:lstStyle/>
           <a:p>
             <a:pPr algn="l">
-              <a:defRPr sz="1300" b="0">
-                <a:solidFill>
-                  <a:srgbClr val="6C757D"/>
+              <a:defRPr sz="1600" b="0">
+                <a:solidFill>
+                  <a:srgbClr val="C0C8D6"/>
                 </a:solidFill>
                 <a:latin typeface="Microsoft JhengHei"/>
               </a:defRPr>
@@ -8449,14 +8449,14 @@
         </p:nvSpPr>
         <p:spPr>
           <a:xfrm>
-            <a:off x="3429000" y="1188720"/>
-            <a:ext cx="2697480" cy="2560320"/>
+            <a:off x="3429000" y="2103120"/>
+            <a:ext cx="2697480" cy="2286000"/>
           </a:xfrm>
           <a:prstGeom prst="roundRect">
             <a:avLst/>
           </a:prstGeom>
           <a:solidFill>
-            <a:srgbClr val="242A40"/>
+            <a:srgbClr val="2B3045"/>
           </a:solidFill>
           <a:ln>
             <a:noFill/>
@@ -8492,7 +8492,7 @@
         </p:nvSpPr>
         <p:spPr>
           <a:xfrm>
-            <a:off x="3429000" y="1188720"/>
+            <a:off x="3429000" y="2103120"/>
             <a:ext cx="2697480" cy="73152"/>
           </a:xfrm>
           <a:prstGeom prst="rect">
@@ -8535,7 +8535,7 @@
         </p:nvSpPr>
         <p:spPr>
           <a:xfrm>
-            <a:off x="3703320" y="1463040"/>
+            <a:off x="3703320" y="2377440"/>
             <a:ext cx="2148840" cy="548640"/>
           </a:xfrm>
           <a:prstGeom prst="rect">
@@ -8550,7 +8550,7 @@
           <a:lstStyle/>
           <a:p>
             <a:pPr algn="l">
-              <a:defRPr sz="1800" b="1">
+              <a:defRPr sz="2000" b="1">
                 <a:solidFill>
                   <a:srgbClr val="7C3AED"/>
                 </a:solidFill>
@@ -8571,8 +8571,8 @@
         </p:nvSpPr>
         <p:spPr>
           <a:xfrm>
-            <a:off x="3703320" y="2194560"/>
-            <a:ext cx="2148840" cy="1371600"/>
+            <a:off x="3703320" y="3017520"/>
+            <a:ext cx="2148840" cy="1280160"/>
           </a:xfrm>
           <a:prstGeom prst="rect">
             <a:avLst/>
@@ -8586,9 +8586,9 @@
           <a:lstStyle/>
           <a:p>
             <a:pPr algn="l">
-              <a:defRPr sz="1300" b="0">
-                <a:solidFill>
-                  <a:srgbClr val="6C757D"/>
+              <a:defRPr sz="1600" b="0">
+                <a:solidFill>
+                  <a:srgbClr val="C0C8D6"/>
                 </a:solidFill>
                 <a:latin typeface="Microsoft JhengHei"/>
               </a:defRPr>
@@ -8615,14 +8615,14 @@
         </p:nvSpPr>
         <p:spPr>
           <a:xfrm>
-            <a:off x="6309359" y="1188720"/>
-            <a:ext cx="2697480" cy="2560320"/>
+            <a:off x="6309359" y="2103120"/>
+            <a:ext cx="2697480" cy="2286000"/>
           </a:xfrm>
           <a:prstGeom prst="roundRect">
             <a:avLst/>
           </a:prstGeom>
           <a:solidFill>
-            <a:srgbClr val="242A40"/>
+            <a:srgbClr val="2B3045"/>
           </a:solidFill>
           <a:ln>
             <a:noFill/>
@@ -8658,7 +8658,7 @@
         </p:nvSpPr>
         <p:spPr>
           <a:xfrm>
-            <a:off x="6309359" y="1188720"/>
+            <a:off x="6309359" y="2103120"/>
             <a:ext cx="2697480" cy="73152"/>
           </a:xfrm>
           <a:prstGeom prst="rect">
@@ -8701,7 +8701,7 @@
         </p:nvSpPr>
         <p:spPr>
           <a:xfrm>
-            <a:off x="6583679" y="1463040"/>
+            <a:off x="6583679" y="2377440"/>
             <a:ext cx="2148840" cy="548640"/>
           </a:xfrm>
           <a:prstGeom prst="rect">
@@ -8716,7 +8716,7 @@
           <a:lstStyle/>
           <a:p>
             <a:pPr algn="l">
-              <a:defRPr sz="1800" b="1">
+              <a:defRPr sz="2000" b="1">
                 <a:solidFill>
                   <a:srgbClr val="00B88D"/>
                 </a:solidFill>
@@ -8737,8 +8737,8 @@
         </p:nvSpPr>
         <p:spPr>
           <a:xfrm>
-            <a:off x="6583679" y="2194560"/>
-            <a:ext cx="2148840" cy="1371600"/>
+            <a:off x="6583679" y="3017520"/>
+            <a:ext cx="2148840" cy="1280160"/>
           </a:xfrm>
           <a:prstGeom prst="rect">
             <a:avLst/>
@@ -8752,9 +8752,9 @@
           <a:lstStyle/>
           <a:p>
             <a:pPr algn="l">
-              <a:defRPr sz="1300" b="0">
-                <a:solidFill>
-                  <a:srgbClr val="6C757D"/>
+              <a:defRPr sz="1600" b="0">
+                <a:solidFill>
+                  <a:srgbClr val="C0C8D6"/>
                 </a:solidFill>
                 <a:latin typeface="Microsoft JhengHei"/>
               </a:defRPr>
@@ -8781,14 +8781,14 @@
         </p:nvSpPr>
         <p:spPr>
           <a:xfrm>
-            <a:off x="9189719" y="1188720"/>
-            <a:ext cx="2697480" cy="2560320"/>
+            <a:off x="9189719" y="2103120"/>
+            <a:ext cx="2697480" cy="2286000"/>
           </a:xfrm>
           <a:prstGeom prst="roundRect">
             <a:avLst/>
           </a:prstGeom>
           <a:solidFill>
-            <a:srgbClr val="242A40"/>
+            <a:srgbClr val="2B3045"/>
           </a:solidFill>
           <a:ln>
             <a:noFill/>
@@ -8824,7 +8824,7 @@
         </p:nvSpPr>
         <p:spPr>
           <a:xfrm>
-            <a:off x="9189719" y="1188720"/>
+            <a:off x="9189719" y="2103120"/>
             <a:ext cx="2697480" cy="73152"/>
           </a:xfrm>
           <a:prstGeom prst="rect">
@@ -8867,7 +8867,7 @@
         </p:nvSpPr>
         <p:spPr>
           <a:xfrm>
-            <a:off x="9464039" y="1463040"/>
+            <a:off x="9464039" y="2377440"/>
             <a:ext cx="2148840" cy="548640"/>
           </a:xfrm>
           <a:prstGeom prst="rect">
@@ -8882,7 +8882,7 @@
           <a:lstStyle/>
           <a:p>
             <a:pPr algn="l">
-              <a:defRPr sz="1800" b="1">
+              <a:defRPr sz="2000" b="1">
                 <a:solidFill>
                   <a:srgbClr val="FF6B35"/>
                 </a:solidFill>
@@ -8903,8 +8903,8 @@
         </p:nvSpPr>
         <p:spPr>
           <a:xfrm>
-            <a:off x="9464039" y="2194560"/>
-            <a:ext cx="2148840" cy="1371600"/>
+            <a:off x="9464039" y="3017520"/>
+            <a:ext cx="2148840" cy="1280160"/>
           </a:xfrm>
           <a:prstGeom prst="rect">
             <a:avLst/>
@@ -8918,9 +8918,9 @@
           <a:lstStyle/>
           <a:p>
             <a:pPr algn="l">
-              <a:defRPr sz="1300" b="0">
-                <a:solidFill>
-                  <a:srgbClr val="6C757D"/>
+              <a:defRPr sz="1600" b="0">
+                <a:solidFill>
+                  <a:srgbClr val="C0C8D6"/>
                 </a:solidFill>
                 <a:latin typeface="Microsoft JhengHei"/>
               </a:defRPr>
@@ -8947,14 +8947,14 @@
         </p:nvSpPr>
         <p:spPr>
           <a:xfrm>
-            <a:off x="548640" y="4023360"/>
-            <a:ext cx="11064240" cy="2011680"/>
+            <a:off x="548640" y="4663440"/>
+            <a:ext cx="11064240" cy="1645920"/>
           </a:xfrm>
           <a:prstGeom prst="roundRect">
             <a:avLst/>
           </a:prstGeom>
           <a:solidFill>
-            <a:srgbClr val="242A40"/>
+            <a:srgbClr val="2B3045"/>
           </a:solidFill>
           <a:ln>
             <a:noFill/>
@@ -8990,7 +8990,7 @@
         </p:nvSpPr>
         <p:spPr>
           <a:xfrm>
-            <a:off x="914400" y="4206240"/>
+            <a:off x="914400" y="4754880"/>
             <a:ext cx="10332720" cy="457200"/>
           </a:xfrm>
           <a:prstGeom prst="rect">
@@ -9005,7 +9005,7 @@
           <a:lstStyle/>
           <a:p>
             <a:pPr algn="l">
-              <a:defRPr sz="2000" b="1">
+              <a:defRPr sz="2200" b="1">
                 <a:solidFill>
                   <a:srgbClr val="00B4D8"/>
                 </a:solidFill>
@@ -9026,7 +9026,7 @@
         </p:nvSpPr>
         <p:spPr>
           <a:xfrm>
-            <a:off x="1097280" y="4754880"/>
+            <a:off x="1097280" y="5303520"/>
             <a:ext cx="10058400" cy="457200"/>
           </a:xfrm>
           <a:prstGeom prst="rect">
@@ -9041,15 +9041,15 @@
           <a:lstStyle/>
           <a:p>
             <a:pPr algn="l">
-              <a:defRPr sz="1400" b="0">
-                <a:solidFill>
-                  <a:srgbClr val="6C757D"/>
-                </a:solidFill>
-                <a:latin typeface="Microsoft JhengHei"/>
-              </a:defRPr>
-            </a:pPr>
-            <a:r>
-              <a:t>傳統 Chatbot：固定腳本 → 只能回答預設問題，超出範圍即轉人工</a:t>
+              <a:defRPr sz="1600" b="0">
+                <a:solidFill>
+                  <a:srgbClr val="C0C8D6"/>
+                </a:solidFill>
+                <a:latin typeface="Microsoft JhengHei"/>
+              </a:defRPr>
+            </a:pPr>
+            <a:r>
+              <a:t>▶ 傳統 Chatbot：固定腳本 → 只能回答預設問題，超出範圍即轉人工</a:t>
             </a:r>
           </a:p>
         </p:txBody>
@@ -9062,7 +9062,7 @@
         </p:nvSpPr>
         <p:spPr>
           <a:xfrm>
-            <a:off x="1097280" y="5212080"/>
+            <a:off x="1097280" y="5760720"/>
             <a:ext cx="10058400" cy="457200"/>
           </a:xfrm>
           <a:prstGeom prst="rect">
@@ -9077,15 +9077,15 @@
           <a:lstStyle/>
           <a:p>
             <a:pPr algn="l">
-              <a:defRPr sz="1400" b="0">
-                <a:solidFill>
-                  <a:srgbClr val="6C757D"/>
-                </a:solidFill>
-                <a:latin typeface="Microsoft JhengHei"/>
-              </a:defRPr>
-            </a:pPr>
-            <a:r>
-              <a:t>AI Agent：LLM 驅動 → 理解開放式對話，自主規劃任務並調用工具完成</a:t>
+              <a:defRPr sz="1600" b="0">
+                <a:solidFill>
+                  <a:srgbClr val="C0C8D6"/>
+                </a:solidFill>
+                <a:latin typeface="Microsoft JhengHei"/>
+              </a:defRPr>
+            </a:pPr>
+            <a:r>
+              <a:t>▶ AI Agent：LLM 驅動 → 理解開放式對話，自主規劃任務並調用工具完成</a:t>
             </a:r>
           </a:p>
         </p:txBody>
@@ -9167,8 +9167,8 @@
         </p:nvSpPr>
         <p:spPr>
           <a:xfrm>
-            <a:off x="914400" y="1828800"/>
-            <a:ext cx="10058400" cy="1371600"/>
+            <a:off x="914400" y="457200"/>
+            <a:ext cx="10058400" cy="1097280"/>
           </a:xfrm>
           <a:prstGeom prst="rect">
             <a:avLst/>
@@ -9203,8 +9203,8 @@
         </p:nvSpPr>
         <p:spPr>
           <a:xfrm>
-            <a:off x="914400" y="3200400"/>
-            <a:ext cx="10058400" cy="914400"/>
+            <a:off x="914400" y="1371600"/>
+            <a:ext cx="10058400" cy="731520"/>
           </a:xfrm>
           <a:prstGeom prst="rect">
             <a:avLst/>
@@ -9218,7 +9218,7 @@
           <a:lstStyle/>
           <a:p>
             <a:pPr algn="l">
-              <a:defRPr sz="2000" b="0">
+              <a:defRPr sz="2400" b="0">
                 <a:solidFill>
                   <a:srgbClr val="00B4D8"/>
                 </a:solidFill>
@@ -9239,14 +9239,14 @@
         </p:nvSpPr>
         <p:spPr>
           <a:xfrm>
-            <a:off x="731520" y="1188720"/>
-            <a:ext cx="10698480" cy="1097280"/>
+            <a:off x="731520" y="2103120"/>
+            <a:ext cx="10698480" cy="914400"/>
           </a:xfrm>
           <a:prstGeom prst="roundRect">
             <a:avLst/>
           </a:prstGeom>
           <a:solidFill>
-            <a:srgbClr val="242A40"/>
+            <a:srgbClr val="2B3045"/>
           </a:solidFill>
           <a:ln>
             <a:noFill/>
@@ -9282,8 +9282,8 @@
         </p:nvSpPr>
         <p:spPr>
           <a:xfrm>
-            <a:off x="731520" y="1188720"/>
-            <a:ext cx="73152" cy="1097280"/>
+            <a:off x="731520" y="2103120"/>
+            <a:ext cx="73152" cy="914400"/>
           </a:xfrm>
           <a:prstGeom prst="rect">
             <a:avLst/>
@@ -9325,8 +9325,8 @@
         </p:nvSpPr>
         <p:spPr>
           <a:xfrm>
-            <a:off x="1097280" y="1234440"/>
-            <a:ext cx="2743200" cy="457200"/>
+            <a:off x="1097280" y="2148840"/>
+            <a:ext cx="2743200" cy="365760"/>
           </a:xfrm>
           <a:prstGeom prst="rect">
             <a:avLst/>
@@ -9340,7 +9340,7 @@
           <a:lstStyle/>
           <a:p>
             <a:pPr algn="l">
-              <a:defRPr sz="1800" b="1">
+              <a:defRPr sz="2000" b="1">
                 <a:solidFill>
                   <a:srgbClr val="006DFF"/>
                 </a:solidFill>
@@ -9361,7 +9361,7 @@
         </p:nvSpPr>
         <p:spPr>
           <a:xfrm>
-            <a:off x="1097280" y="1737360"/>
+            <a:off x="1097280" y="2560320"/>
             <a:ext cx="9601200" cy="457200"/>
           </a:xfrm>
           <a:prstGeom prst="rect">
@@ -9376,9 +9376,9 @@
           <a:lstStyle/>
           <a:p>
             <a:pPr algn="l">
-              <a:defRPr sz="1400" b="0">
-                <a:solidFill>
-                  <a:srgbClr val="6C757D"/>
+              <a:defRPr sz="1600" b="0">
+                <a:solidFill>
+                  <a:srgbClr val="C0C8D6"/>
                 </a:solidFill>
                 <a:latin typeface="Microsoft JhengHei"/>
               </a:defRPr>
@@ -9397,14 +9397,14 @@
         </p:nvSpPr>
         <p:spPr>
           <a:xfrm>
-            <a:off x="731520" y="2423160"/>
-            <a:ext cx="10698480" cy="1097280"/>
+            <a:off x="731520" y="3154680"/>
+            <a:ext cx="10698480" cy="914400"/>
           </a:xfrm>
           <a:prstGeom prst="roundRect">
             <a:avLst/>
           </a:prstGeom>
           <a:solidFill>
-            <a:srgbClr val="242A40"/>
+            <a:srgbClr val="2B3045"/>
           </a:solidFill>
           <a:ln>
             <a:noFill/>
@@ -9440,8 +9440,8 @@
         </p:nvSpPr>
         <p:spPr>
           <a:xfrm>
-            <a:off x="731520" y="2423160"/>
-            <a:ext cx="73152" cy="1097280"/>
+            <a:off x="731520" y="3154680"/>
+            <a:ext cx="73152" cy="914400"/>
           </a:xfrm>
           <a:prstGeom prst="rect">
             <a:avLst/>
@@ -9483,8 +9483,8 @@
         </p:nvSpPr>
         <p:spPr>
           <a:xfrm>
-            <a:off x="1097280" y="2468880"/>
-            <a:ext cx="2743200" cy="457200"/>
+            <a:off x="1097280" y="3200400"/>
+            <a:ext cx="2743200" cy="365760"/>
           </a:xfrm>
           <a:prstGeom prst="rect">
             <a:avLst/>
@@ -9498,7 +9498,7 @@
           <a:lstStyle/>
           <a:p>
             <a:pPr algn="l">
-              <a:defRPr sz="1800" b="1">
+              <a:defRPr sz="2000" b="1">
                 <a:solidFill>
                   <a:srgbClr val="7C3AED"/>
                 </a:solidFill>
@@ -9519,7 +9519,7 @@
         </p:nvSpPr>
         <p:spPr>
           <a:xfrm>
-            <a:off x="1097280" y="2971800"/>
+            <a:off x="1097280" y="3611880"/>
             <a:ext cx="9601200" cy="457200"/>
           </a:xfrm>
           <a:prstGeom prst="rect">
@@ -9534,9 +9534,9 @@
           <a:lstStyle/>
           <a:p>
             <a:pPr algn="l">
-              <a:defRPr sz="1400" b="0">
-                <a:solidFill>
-                  <a:srgbClr val="6C757D"/>
+              <a:defRPr sz="1600" b="0">
+                <a:solidFill>
+                  <a:srgbClr val="C0C8D6"/>
                 </a:solidFill>
                 <a:latin typeface="Microsoft JhengHei"/>
               </a:defRPr>
@@ -9555,14 +9555,14 @@
         </p:nvSpPr>
         <p:spPr>
           <a:xfrm>
-            <a:off x="731520" y="3657600"/>
-            <a:ext cx="10698480" cy="1097280"/>
+            <a:off x="731520" y="4206240"/>
+            <a:ext cx="10698480" cy="914400"/>
           </a:xfrm>
           <a:prstGeom prst="roundRect">
             <a:avLst/>
           </a:prstGeom>
           <a:solidFill>
-            <a:srgbClr val="242A40"/>
+            <a:srgbClr val="2B3045"/>
           </a:solidFill>
           <a:ln>
             <a:noFill/>
@@ -9598,8 +9598,8 @@
         </p:nvSpPr>
         <p:spPr>
           <a:xfrm>
-            <a:off x="731520" y="3657600"/>
-            <a:ext cx="73152" cy="1097280"/>
+            <a:off x="731520" y="4206240"/>
+            <a:ext cx="73152" cy="914400"/>
           </a:xfrm>
           <a:prstGeom prst="rect">
             <a:avLst/>
@@ -9641,8 +9641,8 @@
         </p:nvSpPr>
         <p:spPr>
           <a:xfrm>
-            <a:off x="1097280" y="3703320"/>
-            <a:ext cx="2743200" cy="457200"/>
+            <a:off x="1097280" y="4251960"/>
+            <a:ext cx="2743200" cy="365760"/>
           </a:xfrm>
           <a:prstGeom prst="rect">
             <a:avLst/>
@@ -9656,7 +9656,7 @@
           <a:lstStyle/>
           <a:p>
             <a:pPr algn="l">
-              <a:defRPr sz="1800" b="1">
+              <a:defRPr sz="2000" b="1">
                 <a:solidFill>
                   <a:srgbClr val="00B88D"/>
                 </a:solidFill>
@@ -9677,7 +9677,7 @@
         </p:nvSpPr>
         <p:spPr>
           <a:xfrm>
-            <a:off x="1097280" y="4206240"/>
+            <a:off x="1097280" y="4663440"/>
             <a:ext cx="9601200" cy="457200"/>
           </a:xfrm>
           <a:prstGeom prst="rect">
@@ -9692,9 +9692,9 @@
           <a:lstStyle/>
           <a:p>
             <a:pPr algn="l">
-              <a:defRPr sz="1400" b="0">
-                <a:solidFill>
-                  <a:srgbClr val="6C757D"/>
+              <a:defRPr sz="1600" b="0">
+                <a:solidFill>
+                  <a:srgbClr val="C0C8D6"/>
                 </a:solidFill>
                 <a:latin typeface="Microsoft JhengHei"/>
               </a:defRPr>
@@ -9713,14 +9713,14 @@
         </p:nvSpPr>
         <p:spPr>
           <a:xfrm>
-            <a:off x="731520" y="4892040"/>
-            <a:ext cx="10698480" cy="1097280"/>
+            <a:off x="731520" y="5257800"/>
+            <a:ext cx="10698480" cy="914400"/>
           </a:xfrm>
           <a:prstGeom prst="roundRect">
             <a:avLst/>
           </a:prstGeom>
           <a:solidFill>
-            <a:srgbClr val="242A40"/>
+            <a:srgbClr val="2B3045"/>
           </a:solidFill>
           <a:ln>
             <a:noFill/>
@@ -9756,8 +9756,8 @@
         </p:nvSpPr>
         <p:spPr>
           <a:xfrm>
-            <a:off x="731520" y="4892040"/>
-            <a:ext cx="73152" cy="1097280"/>
+            <a:off x="731520" y="5257800"/>
+            <a:ext cx="73152" cy="914400"/>
           </a:xfrm>
           <a:prstGeom prst="rect">
             <a:avLst/>
@@ -9799,8 +9799,8 @@
         </p:nvSpPr>
         <p:spPr>
           <a:xfrm>
-            <a:off x="1097280" y="4937760"/>
-            <a:ext cx="2743200" cy="457200"/>
+            <a:off x="1097280" y="5303520"/>
+            <a:ext cx="2743200" cy="365760"/>
           </a:xfrm>
           <a:prstGeom prst="rect">
             <a:avLst/>
@@ -9814,7 +9814,7 @@
           <a:lstStyle/>
           <a:p>
             <a:pPr algn="l">
-              <a:defRPr sz="1800" b="1">
+              <a:defRPr sz="2000" b="1">
                 <a:solidFill>
                   <a:srgbClr val="FF6B35"/>
                 </a:solidFill>
@@ -9835,7 +9835,7 @@
         </p:nvSpPr>
         <p:spPr>
           <a:xfrm>
-            <a:off x="1097280" y="5440680"/>
+            <a:off x="1097280" y="5715000"/>
             <a:ext cx="9601200" cy="457200"/>
           </a:xfrm>
           <a:prstGeom prst="rect">
@@ -9850,9 +9850,9 @@
           <a:lstStyle/>
           <a:p>
             <a:pPr algn="l">
-              <a:defRPr sz="1400" b="0">
-                <a:solidFill>
-                  <a:srgbClr val="6C757D"/>
+              <a:defRPr sz="1600" b="0">
+                <a:solidFill>
+                  <a:srgbClr val="C0C8D6"/>
                 </a:solidFill>
                 <a:latin typeface="Microsoft JhengHei"/>
               </a:defRPr>
@@ -9871,7 +9871,7 @@
         </p:nvSpPr>
         <p:spPr>
           <a:xfrm>
-            <a:off x="731520" y="6309360"/>
+            <a:off x="731520" y="6492240"/>
             <a:ext cx="10698480" cy="457200"/>
           </a:xfrm>
           <a:prstGeom prst="rect">
@@ -9886,7 +9886,7 @@
           <a:lstStyle/>
           <a:p>
             <a:pPr algn="ctr">
-              <a:defRPr sz="1500" b="1">
+              <a:defRPr sz="1700" b="1">
                 <a:solidFill>
                   <a:srgbClr val="00B4D8"/>
                 </a:solidFill>
@@ -9976,8 +9976,8 @@
         </p:nvSpPr>
         <p:spPr>
           <a:xfrm>
-            <a:off x="914400" y="1828800"/>
-            <a:ext cx="10058400" cy="1371600"/>
+            <a:off x="914400" y="457200"/>
+            <a:ext cx="10058400" cy="1097280"/>
           </a:xfrm>
           <a:prstGeom prst="rect">
             <a:avLst/>
@@ -10012,8 +10012,8 @@
         </p:nvSpPr>
         <p:spPr>
           <a:xfrm>
-            <a:off x="914400" y="3200400"/>
-            <a:ext cx="10058400" cy="914400"/>
+            <a:off x="914400" y="1371600"/>
+            <a:ext cx="10058400" cy="731520"/>
           </a:xfrm>
           <a:prstGeom prst="rect">
             <a:avLst/>
@@ -10027,7 +10027,7 @@
           <a:lstStyle/>
           <a:p>
             <a:pPr algn="l">
-              <a:defRPr sz="2000" b="0">
+              <a:defRPr sz="2400" b="0">
                 <a:solidFill>
                   <a:srgbClr val="00B4D8"/>
                 </a:solidFill>
@@ -10048,14 +10048,14 @@
         </p:nvSpPr>
         <p:spPr>
           <a:xfrm>
-            <a:off x="457200" y="1188720"/>
-            <a:ext cx="3566160" cy="2377440"/>
+            <a:off x="457200" y="2103120"/>
+            <a:ext cx="3566160" cy="2286000"/>
           </a:xfrm>
           <a:prstGeom prst="roundRect">
             <a:avLst/>
           </a:prstGeom>
           <a:solidFill>
-            <a:srgbClr val="242A40"/>
+            <a:srgbClr val="2B3045"/>
           </a:solidFill>
           <a:ln>
             <a:noFill/>
@@ -10091,7 +10091,7 @@
         </p:nvSpPr>
         <p:spPr>
           <a:xfrm>
-            <a:off x="457200" y="1188720"/>
+            <a:off x="457200" y="2103120"/>
             <a:ext cx="3566160" cy="73152"/>
           </a:xfrm>
           <a:prstGeom prst="rect">
@@ -10134,7 +10134,7 @@
         </p:nvSpPr>
         <p:spPr>
           <a:xfrm>
-            <a:off x="731520" y="1371600"/>
+            <a:off x="731520" y="2286000"/>
             <a:ext cx="3017520" cy="457200"/>
           </a:xfrm>
           <a:prstGeom prst="rect">
@@ -10149,7 +10149,7 @@
           <a:lstStyle/>
           <a:p>
             <a:pPr algn="l">
-              <a:defRPr sz="2000" b="1">
+              <a:defRPr sz="2200" b="1">
                 <a:solidFill>
                   <a:srgbClr val="006DFF"/>
                 </a:solidFill>
@@ -10170,8 +10170,8 @@
         </p:nvSpPr>
         <p:spPr>
           <a:xfrm>
-            <a:off x="731520" y="1920240"/>
-            <a:ext cx="3017520" cy="1463040"/>
+            <a:off x="731520" y="2834640"/>
+            <a:ext cx="3017520" cy="1371600"/>
           </a:xfrm>
           <a:prstGeom prst="rect">
             <a:avLst/>
@@ -10185,9 +10185,9 @@
           <a:lstStyle/>
           <a:p>
             <a:pPr algn="l">
-              <a:defRPr sz="1300" b="0">
-                <a:solidFill>
-                  <a:srgbClr val="6C757D"/>
+              <a:defRPr sz="1600" b="0">
+                <a:solidFill>
+                  <a:srgbClr val="C0C8D6"/>
                 </a:solidFill>
                 <a:latin typeface="Microsoft JhengHei"/>
               </a:defRPr>
@@ -10218,14 +10218,14 @@
         </p:nvSpPr>
         <p:spPr>
           <a:xfrm>
-            <a:off x="4297680" y="1188720"/>
-            <a:ext cx="3566160" cy="2377440"/>
+            <a:off x="4297680" y="2103120"/>
+            <a:ext cx="3566160" cy="2286000"/>
           </a:xfrm>
           <a:prstGeom prst="roundRect">
             <a:avLst/>
           </a:prstGeom>
           <a:solidFill>
-            <a:srgbClr val="242A40"/>
+            <a:srgbClr val="2B3045"/>
           </a:solidFill>
           <a:ln>
             <a:noFill/>
@@ -10261,7 +10261,7 @@
         </p:nvSpPr>
         <p:spPr>
           <a:xfrm>
-            <a:off x="4297680" y="1188720"/>
+            <a:off x="4297680" y="2103120"/>
             <a:ext cx="3566160" cy="73152"/>
           </a:xfrm>
           <a:prstGeom prst="rect">
@@ -10304,7 +10304,7 @@
         </p:nvSpPr>
         <p:spPr>
           <a:xfrm>
-            <a:off x="4572000" y="1371600"/>
+            <a:off x="4572000" y="2286000"/>
             <a:ext cx="3017520" cy="457200"/>
           </a:xfrm>
           <a:prstGeom prst="rect">
@@ -10319,7 +10319,7 @@
           <a:lstStyle/>
           <a:p>
             <a:pPr algn="l">
-              <a:defRPr sz="2000" b="1">
+              <a:defRPr sz="2200" b="1">
                 <a:solidFill>
                   <a:srgbClr val="7C3AED"/>
                 </a:solidFill>
@@ -10340,8 +10340,8 @@
         </p:nvSpPr>
         <p:spPr>
           <a:xfrm>
-            <a:off x="4572000" y="1920240"/>
-            <a:ext cx="3017520" cy="1463040"/>
+            <a:off x="4572000" y="2834640"/>
+            <a:ext cx="3017520" cy="1371600"/>
           </a:xfrm>
           <a:prstGeom prst="rect">
             <a:avLst/>
@@ -10355,9 +10355,9 @@
           <a:lstStyle/>
           <a:p>
             <a:pPr algn="l">
-              <a:defRPr sz="1300" b="0">
-                <a:solidFill>
-                  <a:srgbClr val="6C757D"/>
+              <a:defRPr sz="1600" b="0">
+                <a:solidFill>
+                  <a:srgbClr val="C0C8D6"/>
                 </a:solidFill>
                 <a:latin typeface="Microsoft JhengHei"/>
               </a:defRPr>
@@ -10388,14 +10388,14 @@
         </p:nvSpPr>
         <p:spPr>
           <a:xfrm>
-            <a:off x="8138160" y="1188720"/>
-            <a:ext cx="3566160" cy="2377440"/>
+            <a:off x="8138160" y="2103120"/>
+            <a:ext cx="3566160" cy="2286000"/>
           </a:xfrm>
           <a:prstGeom prst="roundRect">
             <a:avLst/>
           </a:prstGeom>
           <a:solidFill>
-            <a:srgbClr val="242A40"/>
+            <a:srgbClr val="2B3045"/>
           </a:solidFill>
           <a:ln>
             <a:noFill/>
@@ -10431,7 +10431,7 @@
         </p:nvSpPr>
         <p:spPr>
           <a:xfrm>
-            <a:off x="8138160" y="1188720"/>
+            <a:off x="8138160" y="2103120"/>
             <a:ext cx="3566160" cy="73152"/>
           </a:xfrm>
           <a:prstGeom prst="rect">
@@ -10474,7 +10474,7 @@
         </p:nvSpPr>
         <p:spPr>
           <a:xfrm>
-            <a:off x="8412480" y="1371600"/>
+            <a:off x="8412480" y="2286000"/>
             <a:ext cx="3017520" cy="457200"/>
           </a:xfrm>
           <a:prstGeom prst="rect">
@@ -10489,7 +10489,7 @@
           <a:lstStyle/>
           <a:p>
             <a:pPr algn="l">
-              <a:defRPr sz="2000" b="1">
+              <a:defRPr sz="2200" b="1">
                 <a:solidFill>
                   <a:srgbClr val="00B88D"/>
                 </a:solidFill>
@@ -10510,8 +10510,8 @@
         </p:nvSpPr>
         <p:spPr>
           <a:xfrm>
-            <a:off x="8412480" y="1920240"/>
-            <a:ext cx="3017520" cy="1463040"/>
+            <a:off x="8412480" y="2834640"/>
+            <a:ext cx="3017520" cy="1371600"/>
           </a:xfrm>
           <a:prstGeom prst="rect">
             <a:avLst/>
@@ -10525,9 +10525,9 @@
           <a:lstStyle/>
           <a:p>
             <a:pPr algn="l">
-              <a:defRPr sz="1300" b="0">
-                <a:solidFill>
-                  <a:srgbClr val="6C757D"/>
+              <a:defRPr sz="1600" b="0">
+                <a:solidFill>
+                  <a:srgbClr val="C0C8D6"/>
                 </a:solidFill>
                 <a:latin typeface="Microsoft JhengHei"/>
               </a:defRPr>
@@ -10558,14 +10558,14 @@
         </p:nvSpPr>
         <p:spPr>
           <a:xfrm>
-            <a:off x="457200" y="3749039"/>
-            <a:ext cx="11247120" cy="2286000"/>
+            <a:off x="457200" y="4663440"/>
+            <a:ext cx="11247120" cy="1645920"/>
           </a:xfrm>
           <a:prstGeom prst="roundRect">
             <a:avLst/>
           </a:prstGeom>
           <a:solidFill>
-            <a:srgbClr val="242A40"/>
+            <a:srgbClr val="2B3045"/>
           </a:solidFill>
           <a:ln>
             <a:noFill/>
@@ -10601,7 +10601,7 @@
         </p:nvSpPr>
         <p:spPr>
           <a:xfrm>
-            <a:off x="822960" y="3931920"/>
+            <a:off x="822960" y="4754880"/>
             <a:ext cx="10515600" cy="457200"/>
           </a:xfrm>
           <a:prstGeom prst="rect">
@@ -10616,7 +10616,7 @@
           <a:lstStyle/>
           <a:p>
             <a:pPr algn="l">
-              <a:defRPr sz="1800" b="1">
+              <a:defRPr sz="2000" b="1">
                 <a:solidFill>
                   <a:srgbClr val="00B4D8"/>
                 </a:solidFill>
@@ -10637,8 +10637,8 @@
         </p:nvSpPr>
         <p:spPr>
           <a:xfrm>
-            <a:off x="1005840" y="4480560"/>
-            <a:ext cx="10332720" cy="457200"/>
+            <a:off x="1005840" y="5303520"/>
+            <a:ext cx="10332720" cy="365760"/>
           </a:xfrm>
           <a:prstGeom prst="rect">
             <a:avLst/>
@@ -10652,9 +10652,9 @@
           <a:lstStyle/>
           <a:p>
             <a:pPr algn="l">
-              <a:defRPr sz="1300" b="0">
-                <a:solidFill>
-                  <a:srgbClr val="6C757D"/>
+              <a:defRPr sz="1500" b="0">
+                <a:solidFill>
+                  <a:srgbClr val="C0C8D6"/>
                 </a:solidFill>
                 <a:latin typeface="Microsoft JhengHei"/>
               </a:defRPr>
@@ -10673,8 +10673,8 @@
         </p:nvSpPr>
         <p:spPr>
           <a:xfrm>
-            <a:off x="1005840" y="4937760"/>
-            <a:ext cx="10332720" cy="457200"/>
+            <a:off x="1005840" y="5669280"/>
+            <a:ext cx="10332720" cy="365760"/>
           </a:xfrm>
           <a:prstGeom prst="rect">
             <a:avLst/>
@@ -10688,9 +10688,9 @@
           <a:lstStyle/>
           <a:p>
             <a:pPr algn="l">
-              <a:defRPr sz="1300" b="0">
-                <a:solidFill>
-                  <a:srgbClr val="6C757D"/>
+              <a:defRPr sz="1500" b="0">
+                <a:solidFill>
+                  <a:srgbClr val="C0C8D6"/>
                 </a:solidFill>
                 <a:latin typeface="Microsoft JhengHei"/>
               </a:defRPr>
@@ -10709,8 +10709,8 @@
         </p:nvSpPr>
         <p:spPr>
           <a:xfrm>
-            <a:off x="1005840" y="5394960"/>
-            <a:ext cx="10332720" cy="457200"/>
+            <a:off x="1005840" y="6035040"/>
+            <a:ext cx="10332720" cy="365760"/>
           </a:xfrm>
           <a:prstGeom prst="rect">
             <a:avLst/>
@@ -10724,9 +10724,9 @@
           <a:lstStyle/>
           <a:p>
             <a:pPr algn="l">
-              <a:defRPr sz="1300" b="0">
-                <a:solidFill>
-                  <a:srgbClr val="6C757D"/>
+              <a:defRPr sz="1500" b="0">
+                <a:solidFill>
+                  <a:srgbClr val="C0C8D6"/>
                 </a:solidFill>
                 <a:latin typeface="Microsoft JhengHei"/>
               </a:defRPr>
@@ -10814,8 +10814,8 @@
         </p:nvSpPr>
         <p:spPr>
           <a:xfrm>
-            <a:off x="914400" y="1828800"/>
-            <a:ext cx="10058400" cy="1371600"/>
+            <a:off x="914400" y="457200"/>
+            <a:ext cx="10058400" cy="1097280"/>
           </a:xfrm>
           <a:prstGeom prst="rect">
             <a:avLst/>
@@ -10850,8 +10850,8 @@
         </p:nvSpPr>
         <p:spPr>
           <a:xfrm>
-            <a:off x="914400" y="3200400"/>
-            <a:ext cx="10058400" cy="914400"/>
+            <a:off x="914400" y="1371600"/>
+            <a:ext cx="10058400" cy="731520"/>
           </a:xfrm>
           <a:prstGeom prst="rect">
             <a:avLst/>
@@ -10865,7 +10865,7 @@
           <a:lstStyle/>
           <a:p>
             <a:pPr algn="l">
-              <a:defRPr sz="2000" b="0">
+              <a:defRPr sz="2400" b="0">
                 <a:solidFill>
                   <a:srgbClr val="00B4D8"/>
                 </a:solidFill>
@@ -10886,14 +10886,14 @@
         </p:nvSpPr>
         <p:spPr>
           <a:xfrm>
-            <a:off x="457200" y="1188720"/>
-            <a:ext cx="3566160" cy="2377440"/>
+            <a:off x="457200" y="2103120"/>
+            <a:ext cx="3566160" cy="2286000"/>
           </a:xfrm>
           <a:prstGeom prst="roundRect">
             <a:avLst/>
           </a:prstGeom>
           <a:solidFill>
-            <a:srgbClr val="242A40"/>
+            <a:srgbClr val="2B3045"/>
           </a:solidFill>
           <a:ln>
             <a:noFill/>
@@ -10929,7 +10929,7 @@
         </p:nvSpPr>
         <p:spPr>
           <a:xfrm>
-            <a:off x="457200" y="1188720"/>
+            <a:off x="457200" y="2103120"/>
             <a:ext cx="3566160" cy="73152"/>
           </a:xfrm>
           <a:prstGeom prst="rect">
@@ -10972,7 +10972,7 @@
         </p:nvSpPr>
         <p:spPr>
           <a:xfrm>
-            <a:off x="731520" y="1371600"/>
+            <a:off x="731520" y="2286000"/>
             <a:ext cx="3017520" cy="457200"/>
           </a:xfrm>
           <a:prstGeom prst="rect">
@@ -10987,7 +10987,7 @@
           <a:lstStyle/>
           <a:p>
             <a:pPr algn="l">
-              <a:defRPr sz="2000" b="1">
+              <a:defRPr sz="2200" b="1">
                 <a:solidFill>
                   <a:srgbClr val="006DFF"/>
                 </a:solidFill>
@@ -11008,8 +11008,8 @@
         </p:nvSpPr>
         <p:spPr>
           <a:xfrm>
-            <a:off x="731520" y="1920240"/>
-            <a:ext cx="3017520" cy="1463040"/>
+            <a:off x="731520" y="2834640"/>
+            <a:ext cx="3017520" cy="1371600"/>
           </a:xfrm>
           <a:prstGeom prst="rect">
             <a:avLst/>
@@ -11023,9 +11023,9 @@
           <a:lstStyle/>
           <a:p>
             <a:pPr algn="l">
-              <a:defRPr sz="1300" b="0">
-                <a:solidFill>
-                  <a:srgbClr val="6C757D"/>
+              <a:defRPr sz="1600" b="0">
+                <a:solidFill>
+                  <a:srgbClr val="C0C8D6"/>
                 </a:solidFill>
                 <a:latin typeface="Microsoft JhengHei"/>
               </a:defRPr>
@@ -11056,14 +11056,14 @@
         </p:nvSpPr>
         <p:spPr>
           <a:xfrm>
-            <a:off x="4297680" y="1188720"/>
-            <a:ext cx="3566160" cy="2377440"/>
+            <a:off x="4297680" y="2103120"/>
+            <a:ext cx="3566160" cy="2286000"/>
           </a:xfrm>
           <a:prstGeom prst="roundRect">
             <a:avLst/>
           </a:prstGeom>
           <a:solidFill>
-            <a:srgbClr val="242A40"/>
+            <a:srgbClr val="2B3045"/>
           </a:solidFill>
           <a:ln>
             <a:noFill/>
@@ -11099,7 +11099,7 @@
         </p:nvSpPr>
         <p:spPr>
           <a:xfrm>
-            <a:off x="4297680" y="1188720"/>
+            <a:off x="4297680" y="2103120"/>
             <a:ext cx="3566160" cy="73152"/>
           </a:xfrm>
           <a:prstGeom prst="rect">
@@ -11142,7 +11142,7 @@
         </p:nvSpPr>
         <p:spPr>
           <a:xfrm>
-            <a:off x="4572000" y="1371600"/>
+            <a:off x="4572000" y="2286000"/>
             <a:ext cx="3017520" cy="457200"/>
           </a:xfrm>
           <a:prstGeom prst="rect">
@@ -11157,7 +11157,7 @@
           <a:lstStyle/>
           <a:p>
             <a:pPr algn="l">
-              <a:defRPr sz="2000" b="1">
+              <a:defRPr sz="2200" b="1">
                 <a:solidFill>
                   <a:srgbClr val="7C3AED"/>
                 </a:solidFill>
@@ -11178,8 +11178,8 @@
         </p:nvSpPr>
         <p:spPr>
           <a:xfrm>
-            <a:off x="4572000" y="1920240"/>
-            <a:ext cx="3017520" cy="1463040"/>
+            <a:off x="4572000" y="2834640"/>
+            <a:ext cx="3017520" cy="1371600"/>
           </a:xfrm>
           <a:prstGeom prst="rect">
             <a:avLst/>
@@ -11193,9 +11193,9 @@
           <a:lstStyle/>
           <a:p>
             <a:pPr algn="l">
-              <a:defRPr sz="1300" b="0">
-                <a:solidFill>
-                  <a:srgbClr val="6C757D"/>
+              <a:defRPr sz="1600" b="0">
+                <a:solidFill>
+                  <a:srgbClr val="C0C8D6"/>
                 </a:solidFill>
                 <a:latin typeface="Microsoft JhengHei"/>
               </a:defRPr>
@@ -11226,14 +11226,14 @@
         </p:nvSpPr>
         <p:spPr>
           <a:xfrm>
-            <a:off x="8138160" y="1188720"/>
-            <a:ext cx="3566160" cy="2377440"/>
+            <a:off x="8138160" y="2103120"/>
+            <a:ext cx="3566160" cy="2286000"/>
           </a:xfrm>
           <a:prstGeom prst="roundRect">
             <a:avLst/>
           </a:prstGeom>
           <a:solidFill>
-            <a:srgbClr val="242A40"/>
+            <a:srgbClr val="2B3045"/>
           </a:solidFill>
           <a:ln>
             <a:noFill/>
@@ -11269,7 +11269,7 @@
         </p:nvSpPr>
         <p:spPr>
           <a:xfrm>
-            <a:off x="8138160" y="1188720"/>
+            <a:off x="8138160" y="2103120"/>
             <a:ext cx="3566160" cy="73152"/>
           </a:xfrm>
           <a:prstGeom prst="rect">
@@ -11312,7 +11312,7 @@
         </p:nvSpPr>
         <p:spPr>
           <a:xfrm>
-            <a:off x="8412480" y="1371600"/>
+            <a:off x="8412480" y="2286000"/>
             <a:ext cx="3017520" cy="457200"/>
           </a:xfrm>
           <a:prstGeom prst="rect">
@@ -11327,7 +11327,7 @@
           <a:lstStyle/>
           <a:p>
             <a:pPr algn="l">
-              <a:defRPr sz="2000" b="1">
+              <a:defRPr sz="2200" b="1">
                 <a:solidFill>
                   <a:srgbClr val="00B88D"/>
                 </a:solidFill>
@@ -11348,8 +11348,8 @@
         </p:nvSpPr>
         <p:spPr>
           <a:xfrm>
-            <a:off x="8412480" y="1920240"/>
-            <a:ext cx="3017520" cy="1463040"/>
+            <a:off x="8412480" y="2834640"/>
+            <a:ext cx="3017520" cy="1371600"/>
           </a:xfrm>
           <a:prstGeom prst="rect">
             <a:avLst/>
@@ -11363,9 +11363,9 @@
           <a:lstStyle/>
           <a:p>
             <a:pPr algn="l">
-              <a:defRPr sz="1300" b="0">
-                <a:solidFill>
-                  <a:srgbClr val="6C757D"/>
+              <a:defRPr sz="1600" b="0">
+                <a:solidFill>
+                  <a:srgbClr val="C0C8D6"/>
                 </a:solidFill>
                 <a:latin typeface="Microsoft JhengHei"/>
               </a:defRPr>
@@ -11396,14 +11396,14 @@
         </p:nvSpPr>
         <p:spPr>
           <a:xfrm>
-            <a:off x="457200" y="3749039"/>
-            <a:ext cx="11247120" cy="2286000"/>
+            <a:off x="457200" y="4663440"/>
+            <a:ext cx="11247120" cy="1645920"/>
           </a:xfrm>
           <a:prstGeom prst="roundRect">
             <a:avLst/>
           </a:prstGeom>
           <a:solidFill>
-            <a:srgbClr val="242A40"/>
+            <a:srgbClr val="2B3045"/>
           </a:solidFill>
           <a:ln>
             <a:noFill/>
@@ -11439,7 +11439,7 @@
         </p:nvSpPr>
         <p:spPr>
           <a:xfrm>
-            <a:off x="822960" y="3931920"/>
+            <a:off x="822960" y="4754880"/>
             <a:ext cx="10515600" cy="457200"/>
           </a:xfrm>
           <a:prstGeom prst="rect">
@@ -11454,7 +11454,7 @@
           <a:lstStyle/>
           <a:p>
             <a:pPr algn="l">
-              <a:defRPr sz="1800" b="1">
+              <a:defRPr sz="2000" b="1">
                 <a:solidFill>
                   <a:srgbClr val="00B4D8"/>
                 </a:solidFill>
@@ -11475,8 +11475,8 @@
         </p:nvSpPr>
         <p:spPr>
           <a:xfrm>
-            <a:off x="1005840" y="4480560"/>
-            <a:ext cx="10332720" cy="457200"/>
+            <a:off x="1005840" y="5303520"/>
+            <a:ext cx="10332720" cy="365760"/>
           </a:xfrm>
           <a:prstGeom prst="rect">
             <a:avLst/>
@@ -11490,9 +11490,9 @@
           <a:lstStyle/>
           <a:p>
             <a:pPr algn="l">
-              <a:defRPr sz="1300" b="0">
-                <a:solidFill>
-                  <a:srgbClr val="6C757D"/>
+              <a:defRPr sz="1500" b="0">
+                <a:solidFill>
+                  <a:srgbClr val="C0C8D6"/>
                 </a:solidFill>
                 <a:latin typeface="Microsoft JhengHei"/>
               </a:defRPr>
@@ -11511,8 +11511,8 @@
         </p:nvSpPr>
         <p:spPr>
           <a:xfrm>
-            <a:off x="1005840" y="4937760"/>
-            <a:ext cx="10332720" cy="457200"/>
+            <a:off x="1005840" y="5669280"/>
+            <a:ext cx="10332720" cy="365760"/>
           </a:xfrm>
           <a:prstGeom prst="rect">
             <a:avLst/>
@@ -11526,9 +11526,9 @@
           <a:lstStyle/>
           <a:p>
             <a:pPr algn="l">
-              <a:defRPr sz="1300" b="0">
-                <a:solidFill>
-                  <a:srgbClr val="6C757D"/>
+              <a:defRPr sz="1500" b="0">
+                <a:solidFill>
+                  <a:srgbClr val="C0C8D6"/>
                 </a:solidFill>
                 <a:latin typeface="Microsoft JhengHei"/>
               </a:defRPr>
@@ -11547,8 +11547,8 @@
         </p:nvSpPr>
         <p:spPr>
           <a:xfrm>
-            <a:off x="1005840" y="5394960"/>
-            <a:ext cx="10332720" cy="457200"/>
+            <a:off x="1005840" y="6035040"/>
+            <a:ext cx="10332720" cy="365760"/>
           </a:xfrm>
           <a:prstGeom prst="rect">
             <a:avLst/>
@@ -11562,9 +11562,9 @@
           <a:lstStyle/>
           <a:p>
             <a:pPr algn="l">
-              <a:defRPr sz="1300" b="0">
-                <a:solidFill>
-                  <a:srgbClr val="6C757D"/>
+              <a:defRPr sz="1500" b="0">
+                <a:solidFill>
+                  <a:srgbClr val="C0C8D6"/>
                 </a:solidFill>
                 <a:latin typeface="Microsoft JhengHei"/>
               </a:defRPr>
@@ -11652,8 +11652,8 @@
         </p:nvSpPr>
         <p:spPr>
           <a:xfrm>
-            <a:off x="914400" y="1828800"/>
-            <a:ext cx="10058400" cy="1371600"/>
+            <a:off x="914400" y="457200"/>
+            <a:ext cx="10058400" cy="1097280"/>
           </a:xfrm>
           <a:prstGeom prst="rect">
             <a:avLst/>
@@ -11688,8 +11688,8 @@
         </p:nvSpPr>
         <p:spPr>
           <a:xfrm>
-            <a:off x="914400" y="3200400"/>
-            <a:ext cx="10058400" cy="914400"/>
+            <a:off x="914400" y="1371600"/>
+            <a:ext cx="10058400" cy="731520"/>
           </a:xfrm>
           <a:prstGeom prst="rect">
             <a:avLst/>
@@ -11703,7 +11703,7 @@
           <a:lstStyle/>
           <a:p>
             <a:pPr algn="l">
-              <a:defRPr sz="2000" b="0">
+              <a:defRPr sz="2400" b="0">
                 <a:solidFill>
                   <a:srgbClr val="00B4D8"/>
                 </a:solidFill>
@@ -11724,14 +11724,14 @@
         </p:nvSpPr>
         <p:spPr>
           <a:xfrm>
-            <a:off x="548640" y="1188720"/>
-            <a:ext cx="2697480" cy="2286000"/>
+            <a:off x="548640" y="2103120"/>
+            <a:ext cx="2697480" cy="2011680"/>
           </a:xfrm>
           <a:prstGeom prst="roundRect">
             <a:avLst/>
           </a:prstGeom>
           <a:solidFill>
-            <a:srgbClr val="242A40"/>
+            <a:srgbClr val="2B3045"/>
           </a:solidFill>
           <a:ln>
             <a:noFill/>
@@ -11767,7 +11767,7 @@
         </p:nvSpPr>
         <p:spPr>
           <a:xfrm>
-            <a:off x="548640" y="1188720"/>
+            <a:off x="548640" y="2103120"/>
             <a:ext cx="2697480" cy="73152"/>
           </a:xfrm>
           <a:prstGeom prst="rect">
@@ -11810,7 +11810,7 @@
         </p:nvSpPr>
         <p:spPr>
           <a:xfrm>
-            <a:off x="822960" y="1463040"/>
+            <a:off x="822960" y="2377440"/>
             <a:ext cx="2148840" cy="457200"/>
           </a:xfrm>
           <a:prstGeom prst="rect">
@@ -11825,7 +11825,7 @@
           <a:lstStyle/>
           <a:p>
             <a:pPr algn="l">
-              <a:defRPr sz="1800" b="1">
+              <a:defRPr sz="2000" b="1">
                 <a:solidFill>
                   <a:srgbClr val="006DFF"/>
                 </a:solidFill>
@@ -11846,8 +11846,8 @@
         </p:nvSpPr>
         <p:spPr>
           <a:xfrm>
-            <a:off x="822960" y="2011680"/>
-            <a:ext cx="2148840" cy="1371600"/>
+            <a:off x="822960" y="2926080"/>
+            <a:ext cx="2148840" cy="1097280"/>
           </a:xfrm>
           <a:prstGeom prst="rect">
             <a:avLst/>
@@ -11861,9 +11861,9 @@
           <a:lstStyle/>
           <a:p>
             <a:pPr algn="l">
-              <a:defRPr sz="1300" b="0">
-                <a:solidFill>
-                  <a:srgbClr val="6C757D"/>
+              <a:defRPr sz="1600" b="0">
+                <a:solidFill>
+                  <a:srgbClr val="C0C8D6"/>
                 </a:solidFill>
                 <a:latin typeface="Microsoft JhengHei"/>
               </a:defRPr>
@@ -11890,14 +11890,14 @@
         </p:nvSpPr>
         <p:spPr>
           <a:xfrm>
-            <a:off x="3429000" y="1188720"/>
-            <a:ext cx="2697480" cy="2286000"/>
+            <a:off x="3429000" y="2103120"/>
+            <a:ext cx="2697480" cy="2011680"/>
           </a:xfrm>
           <a:prstGeom prst="roundRect">
             <a:avLst/>
           </a:prstGeom>
           <a:solidFill>
-            <a:srgbClr val="242A40"/>
+            <a:srgbClr val="2B3045"/>
           </a:solidFill>
           <a:ln>
             <a:noFill/>
@@ -11933,7 +11933,7 @@
         </p:nvSpPr>
         <p:spPr>
           <a:xfrm>
-            <a:off x="3429000" y="1188720"/>
+            <a:off x="3429000" y="2103120"/>
             <a:ext cx="2697480" cy="73152"/>
           </a:xfrm>
           <a:prstGeom prst="rect">
@@ -11976,7 +11976,7 @@
         </p:nvSpPr>
         <p:spPr>
           <a:xfrm>
-            <a:off x="3703320" y="1463040"/>
+            <a:off x="3703320" y="2377440"/>
             <a:ext cx="2148840" cy="457200"/>
           </a:xfrm>
           <a:prstGeom prst="rect">
@@ -11991,7 +11991,7 @@
           <a:lstStyle/>
           <a:p>
             <a:pPr algn="l">
-              <a:defRPr sz="1800" b="1">
+              <a:defRPr sz="2000" b="1">
                 <a:solidFill>
                   <a:srgbClr val="7C3AED"/>
                 </a:solidFill>
@@ -12012,8 +12012,8 @@
         </p:nvSpPr>
         <p:spPr>
           <a:xfrm>
-            <a:off x="3703320" y="2011680"/>
-            <a:ext cx="2148840" cy="1371600"/>
+            <a:off x="3703320" y="2926080"/>
+            <a:ext cx="2148840" cy="1097280"/>
           </a:xfrm>
           <a:prstGeom prst="rect">
             <a:avLst/>
@@ -12027,9 +12027,9 @@
           <a:lstStyle/>
           <a:p>
             <a:pPr algn="l">
-              <a:defRPr sz="1300" b="0">
-                <a:solidFill>
-                  <a:srgbClr val="6C757D"/>
+              <a:defRPr sz="1600" b="0">
+                <a:solidFill>
+                  <a:srgbClr val="C0C8D6"/>
                 </a:solidFill>
                 <a:latin typeface="Microsoft JhengHei"/>
               </a:defRPr>
@@ -12056,14 +12056,14 @@
         </p:nvSpPr>
         <p:spPr>
           <a:xfrm>
-            <a:off x="6309359" y="1188720"/>
-            <a:ext cx="2697480" cy="2286000"/>
+            <a:off x="6309359" y="2103120"/>
+            <a:ext cx="2697480" cy="2011680"/>
           </a:xfrm>
           <a:prstGeom prst="roundRect">
             <a:avLst/>
           </a:prstGeom>
           <a:solidFill>
-            <a:srgbClr val="242A40"/>
+            <a:srgbClr val="2B3045"/>
           </a:solidFill>
           <a:ln>
             <a:noFill/>
@@ -12099,7 +12099,7 @@
         </p:nvSpPr>
         <p:spPr>
           <a:xfrm>
-            <a:off x="6309359" y="1188720"/>
+            <a:off x="6309359" y="2103120"/>
             <a:ext cx="2697480" cy="73152"/>
           </a:xfrm>
           <a:prstGeom prst="rect">
@@ -12142,7 +12142,7 @@
         </p:nvSpPr>
         <p:spPr>
           <a:xfrm>
-            <a:off x="6583679" y="1463040"/>
+            <a:off x="6583679" y="2377440"/>
             <a:ext cx="2148840" cy="457200"/>
           </a:xfrm>
           <a:prstGeom prst="rect">
@@ -12157,7 +12157,7 @@
           <a:lstStyle/>
           <a:p>
             <a:pPr algn="l">
-              <a:defRPr sz="1800" b="1">
+              <a:defRPr sz="2000" b="1">
                 <a:solidFill>
                   <a:srgbClr val="00B88D"/>
                 </a:solidFill>
@@ -12178,8 +12178,8 @@
         </p:nvSpPr>
         <p:spPr>
           <a:xfrm>
-            <a:off x="6583679" y="2011680"/>
-            <a:ext cx="2148840" cy="1371600"/>
+            <a:off x="6583679" y="2926080"/>
+            <a:ext cx="2148840" cy="1097280"/>
           </a:xfrm>
           <a:prstGeom prst="rect">
             <a:avLst/>
@@ -12193,9 +12193,9 @@
           <a:lstStyle/>
           <a:p>
             <a:pPr algn="l">
-              <a:defRPr sz="1300" b="0">
-                <a:solidFill>
-                  <a:srgbClr val="6C757D"/>
+              <a:defRPr sz="1600" b="0">
+                <a:solidFill>
+                  <a:srgbClr val="C0C8D6"/>
                 </a:solidFill>
                 <a:latin typeface="Microsoft JhengHei"/>
               </a:defRPr>
@@ -12222,14 +12222,14 @@
         </p:nvSpPr>
         <p:spPr>
           <a:xfrm>
-            <a:off x="9189719" y="1188720"/>
-            <a:ext cx="2697480" cy="2286000"/>
+            <a:off x="9189719" y="2103120"/>
+            <a:ext cx="2697480" cy="2011680"/>
           </a:xfrm>
           <a:prstGeom prst="roundRect">
             <a:avLst/>
           </a:prstGeom>
           <a:solidFill>
-            <a:srgbClr val="242A40"/>
+            <a:srgbClr val="2B3045"/>
           </a:solidFill>
           <a:ln>
             <a:noFill/>
@@ -12265,7 +12265,7 @@
         </p:nvSpPr>
         <p:spPr>
           <a:xfrm>
-            <a:off x="9189719" y="1188720"/>
+            <a:off x="9189719" y="2103120"/>
             <a:ext cx="2697480" cy="73152"/>
           </a:xfrm>
           <a:prstGeom prst="rect">
@@ -12308,7 +12308,7 @@
         </p:nvSpPr>
         <p:spPr>
           <a:xfrm>
-            <a:off x="9464039" y="1463040"/>
+            <a:off x="9464039" y="2377440"/>
             <a:ext cx="2148840" cy="457200"/>
           </a:xfrm>
           <a:prstGeom prst="rect">
@@ -12323,7 +12323,7 @@
           <a:lstStyle/>
           <a:p>
             <a:pPr algn="l">
-              <a:defRPr sz="1800" b="1">
+              <a:defRPr sz="2000" b="1">
                 <a:solidFill>
                   <a:srgbClr val="FF6B35"/>
                 </a:solidFill>
@@ -12344,8 +12344,8 @@
         </p:nvSpPr>
         <p:spPr>
           <a:xfrm>
-            <a:off x="9464039" y="2011680"/>
-            <a:ext cx="2148840" cy="1371600"/>
+            <a:off x="9464039" y="2926080"/>
+            <a:ext cx="2148840" cy="1097280"/>
           </a:xfrm>
           <a:prstGeom prst="rect">
             <a:avLst/>
@@ -12359,9 +12359,9 @@
           <a:lstStyle/>
           <a:p>
             <a:pPr algn="l">
-              <a:defRPr sz="1300" b="0">
-                <a:solidFill>
-                  <a:srgbClr val="6C757D"/>
+              <a:defRPr sz="1600" b="0">
+                <a:solidFill>
+                  <a:srgbClr val="C0C8D6"/>
                 </a:solidFill>
                 <a:latin typeface="Microsoft JhengHei"/>
               </a:defRPr>
@@ -12388,14 +12388,14 @@
         </p:nvSpPr>
         <p:spPr>
           <a:xfrm>
-            <a:off x="548640" y="3749039"/>
-            <a:ext cx="11064240" cy="2286000"/>
+            <a:off x="548640" y="4389120"/>
+            <a:ext cx="11064240" cy="2011680"/>
           </a:xfrm>
           <a:prstGeom prst="roundRect">
             <a:avLst/>
           </a:prstGeom>
           <a:solidFill>
-            <a:srgbClr val="242A40"/>
+            <a:srgbClr val="2B3045"/>
           </a:solidFill>
           <a:ln>
             <a:noFill/>
@@ -12431,7 +12431,7 @@
         </p:nvSpPr>
         <p:spPr>
           <a:xfrm>
-            <a:off x="914400" y="3931920"/>
+            <a:off x="914400" y="4480560"/>
             <a:ext cx="10332720" cy="457200"/>
           </a:xfrm>
           <a:prstGeom prst="rect">
@@ -12446,7 +12446,7 @@
           <a:lstStyle/>
           <a:p>
             <a:pPr algn="l">
-              <a:defRPr sz="1800" b="1">
+              <a:defRPr sz="2000" b="1">
                 <a:solidFill>
                   <a:srgbClr val="00B4D8"/>
                 </a:solidFill>
@@ -12467,7 +12467,7 @@
         </p:nvSpPr>
         <p:spPr>
           <a:xfrm>
-            <a:off x="1097280" y="4480560"/>
+            <a:off x="1097280" y="5029200"/>
             <a:ext cx="10058400" cy="365760"/>
           </a:xfrm>
           <a:prstGeom prst="rect">
@@ -12482,9 +12482,9 @@
           <a:lstStyle/>
           <a:p>
             <a:pPr algn="l">
-              <a:defRPr sz="1300" b="0">
-                <a:solidFill>
-                  <a:srgbClr val="6C757D"/>
+              <a:defRPr sz="1500" b="0">
+                <a:solidFill>
+                  <a:srgbClr val="C0C8D6"/>
                 </a:solidFill>
                 <a:latin typeface="Microsoft JhengHei"/>
               </a:defRPr>
@@ -12503,7 +12503,7 @@
         </p:nvSpPr>
         <p:spPr>
           <a:xfrm>
-            <a:off x="1097280" y="4846320"/>
+            <a:off x="1097280" y="5394960"/>
             <a:ext cx="10058400" cy="365760"/>
           </a:xfrm>
           <a:prstGeom prst="rect">
@@ -12518,9 +12518,9 @@
           <a:lstStyle/>
           <a:p>
             <a:pPr algn="l">
-              <a:defRPr sz="1300" b="0">
-                <a:solidFill>
-                  <a:srgbClr val="6C757D"/>
+              <a:defRPr sz="1500" b="0">
+                <a:solidFill>
+                  <a:srgbClr val="C0C8D6"/>
                 </a:solidFill>
                 <a:latin typeface="Microsoft JhengHei"/>
               </a:defRPr>
@@ -12539,7 +12539,7 @@
         </p:nvSpPr>
         <p:spPr>
           <a:xfrm>
-            <a:off x="1097280" y="5212080"/>
+            <a:off x="1097280" y="5760720"/>
             <a:ext cx="10058400" cy="365760"/>
           </a:xfrm>
           <a:prstGeom prst="rect">
@@ -12554,9 +12554,9 @@
           <a:lstStyle/>
           <a:p>
             <a:pPr algn="l">
-              <a:defRPr sz="1300" b="0">
-                <a:solidFill>
-                  <a:srgbClr val="6C757D"/>
+              <a:defRPr sz="1500" b="0">
+                <a:solidFill>
+                  <a:srgbClr val="C0C8D6"/>
                 </a:solidFill>
                 <a:latin typeface="Microsoft JhengHei"/>
               </a:defRPr>
@@ -12575,7 +12575,7 @@
         </p:nvSpPr>
         <p:spPr>
           <a:xfrm>
-            <a:off x="1097280" y="5577840"/>
+            <a:off x="1097280" y="6126480"/>
             <a:ext cx="10058400" cy="365760"/>
           </a:xfrm>
           <a:prstGeom prst="rect">
@@ -12590,9 +12590,9 @@
           <a:lstStyle/>
           <a:p>
             <a:pPr algn="l">
-              <a:defRPr sz="1300" b="0">
-                <a:solidFill>
-                  <a:srgbClr val="6C757D"/>
+              <a:defRPr sz="1500" b="0">
+                <a:solidFill>
+                  <a:srgbClr val="C0C8D6"/>
                 </a:solidFill>
                 <a:latin typeface="Microsoft JhengHei"/>
               </a:defRPr>
@@ -12680,8 +12680,8 @@
         </p:nvSpPr>
         <p:spPr>
           <a:xfrm>
-            <a:off x="914400" y="1828800"/>
-            <a:ext cx="10058400" cy="1371600"/>
+            <a:off x="914400" y="457200"/>
+            <a:ext cx="10058400" cy="1097280"/>
           </a:xfrm>
           <a:prstGeom prst="rect">
             <a:avLst/>
@@ -12716,8 +12716,8 @@
         </p:nvSpPr>
         <p:spPr>
           <a:xfrm>
-            <a:off x="914400" y="3200400"/>
-            <a:ext cx="10058400" cy="914400"/>
+            <a:off x="914400" y="1371600"/>
+            <a:ext cx="10058400" cy="731520"/>
           </a:xfrm>
           <a:prstGeom prst="rect">
             <a:avLst/>
@@ -12731,7 +12731,7 @@
           <a:lstStyle/>
           <a:p>
             <a:pPr algn="l">
-              <a:defRPr sz="2000" b="0">
+              <a:defRPr sz="2400" b="0">
                 <a:solidFill>
                   <a:srgbClr val="00B4D8"/>
                 </a:solidFill>
@@ -12752,14 +12752,14 @@
         </p:nvSpPr>
         <p:spPr>
           <a:xfrm>
-            <a:off x="548640" y="1188720"/>
-            <a:ext cx="2697480" cy="2560320"/>
+            <a:off x="548640" y="2103120"/>
+            <a:ext cx="2697480" cy="2286000"/>
           </a:xfrm>
           <a:prstGeom prst="roundRect">
             <a:avLst/>
           </a:prstGeom>
           <a:solidFill>
-            <a:srgbClr val="242A40"/>
+            <a:srgbClr val="2B3045"/>
           </a:solidFill>
           <a:ln>
             <a:noFill/>
@@ -12795,7 +12795,7 @@
         </p:nvSpPr>
         <p:spPr>
           <a:xfrm>
-            <a:off x="548640" y="1188720"/>
+            <a:off x="548640" y="2103120"/>
             <a:ext cx="2697480" cy="73152"/>
           </a:xfrm>
           <a:prstGeom prst="rect">
@@ -12838,7 +12838,7 @@
         </p:nvSpPr>
         <p:spPr>
           <a:xfrm>
-            <a:off x="731520" y="1463040"/>
+            <a:off x="731520" y="2377440"/>
             <a:ext cx="2331720" cy="914400"/>
           </a:xfrm>
           <a:prstGeom prst="rect">
@@ -12874,7 +12874,7 @@
         </p:nvSpPr>
         <p:spPr>
           <a:xfrm>
-            <a:off x="731520" y="2468880"/>
+            <a:off x="731520" y="3291840"/>
             <a:ext cx="2331720" cy="457200"/>
           </a:xfrm>
           <a:prstGeom prst="rect">
@@ -12889,7 +12889,7 @@
           <a:lstStyle/>
           <a:p>
             <a:pPr algn="ctr">
-              <a:defRPr sz="1800" b="1">
+              <a:defRPr sz="2000" b="1">
                 <a:solidFill>
                   <a:srgbClr val="FFFFFF"/>
                 </a:solidFill>
@@ -12910,8 +12910,8 @@
         </p:nvSpPr>
         <p:spPr>
           <a:xfrm>
-            <a:off x="731520" y="2926080"/>
-            <a:ext cx="2331720" cy="548640"/>
+            <a:off x="731520" y="3749040"/>
+            <a:ext cx="2331720" cy="457200"/>
           </a:xfrm>
           <a:prstGeom prst="rect">
             <a:avLst/>
@@ -12925,9 +12925,9 @@
           <a:lstStyle/>
           <a:p>
             <a:pPr algn="ctr">
-              <a:defRPr sz="1200" b="0">
-                <a:solidFill>
-                  <a:srgbClr val="6C757D"/>
+              <a:defRPr sz="1500" b="0">
+                <a:solidFill>
+                  <a:srgbClr val="C0C8D6"/>
                 </a:solidFill>
                 <a:latin typeface="Microsoft JhengHei"/>
               </a:defRPr>
@@ -12946,14 +12946,14 @@
         </p:nvSpPr>
         <p:spPr>
           <a:xfrm>
-            <a:off x="3429000" y="1188720"/>
-            <a:ext cx="2697480" cy="2560320"/>
+            <a:off x="3429000" y="2103120"/>
+            <a:ext cx="2697480" cy="2286000"/>
           </a:xfrm>
           <a:prstGeom prst="roundRect">
             <a:avLst/>
           </a:prstGeom>
           <a:solidFill>
-            <a:srgbClr val="242A40"/>
+            <a:srgbClr val="2B3045"/>
           </a:solidFill>
           <a:ln>
             <a:noFill/>
@@ -12989,7 +12989,7 @@
         </p:nvSpPr>
         <p:spPr>
           <a:xfrm>
-            <a:off x="3429000" y="1188720"/>
+            <a:off x="3429000" y="2103120"/>
             <a:ext cx="2697480" cy="73152"/>
           </a:xfrm>
           <a:prstGeom prst="rect">
@@ -13032,7 +13032,7 @@
         </p:nvSpPr>
         <p:spPr>
           <a:xfrm>
-            <a:off x="3611880" y="1463040"/>
+            <a:off x="3611880" y="2377440"/>
             <a:ext cx="2331720" cy="914400"/>
           </a:xfrm>
           <a:prstGeom prst="rect">
@@ -13068,7 +13068,7 @@
         </p:nvSpPr>
         <p:spPr>
           <a:xfrm>
-            <a:off x="3611880" y="2468880"/>
+            <a:off x="3611880" y="3291840"/>
             <a:ext cx="2331720" cy="457200"/>
           </a:xfrm>
           <a:prstGeom prst="rect">
@@ -13083,7 +13083,7 @@
           <a:lstStyle/>
           <a:p>
             <a:pPr algn="ctr">
-              <a:defRPr sz="1800" b="1">
+              <a:defRPr sz="2000" b="1">
                 <a:solidFill>
                   <a:srgbClr val="FFFFFF"/>
                 </a:solidFill>
@@ -13104,8 +13104,8 @@
         </p:nvSpPr>
         <p:spPr>
           <a:xfrm>
-            <a:off x="3611880" y="2926080"/>
-            <a:ext cx="2331720" cy="548640"/>
+            <a:off x="3611880" y="3749040"/>
+            <a:ext cx="2331720" cy="457200"/>
           </a:xfrm>
           <a:prstGeom prst="rect">
             <a:avLst/>
@@ -13119,9 +13119,9 @@
           <a:lstStyle/>
           <a:p>
             <a:pPr algn="ctr">
-              <a:defRPr sz="1200" b="0">
-                <a:solidFill>
-                  <a:srgbClr val="6C757D"/>
+              <a:defRPr sz="1500" b="0">
+                <a:solidFill>
+                  <a:srgbClr val="C0C8D6"/>
                 </a:solidFill>
                 <a:latin typeface="Microsoft JhengHei"/>
               </a:defRPr>
@@ -13140,14 +13140,14 @@
         </p:nvSpPr>
         <p:spPr>
           <a:xfrm>
-            <a:off x="6309359" y="1188720"/>
-            <a:ext cx="2697480" cy="2560320"/>
+            <a:off x="6309359" y="2103120"/>
+            <a:ext cx="2697480" cy="2286000"/>
           </a:xfrm>
           <a:prstGeom prst="roundRect">
             <a:avLst/>
           </a:prstGeom>
           <a:solidFill>
-            <a:srgbClr val="242A40"/>
+            <a:srgbClr val="2B3045"/>
           </a:solidFill>
           <a:ln>
             <a:noFill/>
@@ -13183,7 +13183,7 @@
         </p:nvSpPr>
         <p:spPr>
           <a:xfrm>
-            <a:off x="6309359" y="1188720"/>
+            <a:off x="6309359" y="2103120"/>
             <a:ext cx="2697480" cy="73152"/>
           </a:xfrm>
           <a:prstGeom prst="rect">
@@ -13226,7 +13226,7 @@
         </p:nvSpPr>
         <p:spPr>
           <a:xfrm>
-            <a:off x="6492239" y="1463040"/>
+            <a:off x="6492239" y="2377440"/>
             <a:ext cx="2331720" cy="914400"/>
           </a:xfrm>
           <a:prstGeom prst="rect">
@@ -13262,7 +13262,7 @@
         </p:nvSpPr>
         <p:spPr>
           <a:xfrm>
-            <a:off x="6492239" y="2468880"/>
+            <a:off x="6492239" y="3291840"/>
             <a:ext cx="2331720" cy="457200"/>
           </a:xfrm>
           <a:prstGeom prst="rect">
@@ -13277,7 +13277,7 @@
           <a:lstStyle/>
           <a:p>
             <a:pPr algn="ctr">
-              <a:defRPr sz="1800" b="1">
+              <a:defRPr sz="2000" b="1">
                 <a:solidFill>
                   <a:srgbClr val="FFFFFF"/>
                 </a:solidFill>
@@ -13298,8 +13298,8 @@
         </p:nvSpPr>
         <p:spPr>
           <a:xfrm>
-            <a:off x="6492239" y="2926080"/>
-            <a:ext cx="2331720" cy="548640"/>
+            <a:off x="6492239" y="3749040"/>
+            <a:ext cx="2331720" cy="457200"/>
           </a:xfrm>
           <a:prstGeom prst="rect">
             <a:avLst/>
@@ -13313,9 +13313,9 @@
           <a:lstStyle/>
           <a:p>
             <a:pPr algn="ctr">
-              <a:defRPr sz="1200" b="0">
-                <a:solidFill>
-                  <a:srgbClr val="6C757D"/>
+              <a:defRPr sz="1500" b="0">
+                <a:solidFill>
+                  <a:srgbClr val="C0C8D6"/>
                 </a:solidFill>
                 <a:latin typeface="Microsoft JhengHei"/>
               </a:defRPr>
@@ -13334,14 +13334,14 @@
         </p:nvSpPr>
         <p:spPr>
           <a:xfrm>
-            <a:off x="9189719" y="1188720"/>
-            <a:ext cx="2697480" cy="2560320"/>
+            <a:off x="9189719" y="2103120"/>
+            <a:ext cx="2697480" cy="2286000"/>
           </a:xfrm>
           <a:prstGeom prst="roundRect">
             <a:avLst/>
           </a:prstGeom>
           <a:solidFill>
-            <a:srgbClr val="242A40"/>
+            <a:srgbClr val="2B3045"/>
           </a:solidFill>
           <a:ln>
             <a:noFill/>
@@ -13377,7 +13377,7 @@
         </p:nvSpPr>
         <p:spPr>
           <a:xfrm>
-            <a:off x="9189719" y="1188720"/>
+            <a:off x="9189719" y="2103120"/>
             <a:ext cx="2697480" cy="73152"/>
           </a:xfrm>
           <a:prstGeom prst="rect">
@@ -13420,7 +13420,7 @@
         </p:nvSpPr>
         <p:spPr>
           <a:xfrm>
-            <a:off x="9372599" y="1463040"/>
+            <a:off x="9372599" y="2377440"/>
             <a:ext cx="2331720" cy="914400"/>
           </a:xfrm>
           <a:prstGeom prst="rect">
@@ -13456,7 +13456,7 @@
         </p:nvSpPr>
         <p:spPr>
           <a:xfrm>
-            <a:off x="9372599" y="2468880"/>
+            <a:off x="9372599" y="3291840"/>
             <a:ext cx="2331720" cy="457200"/>
           </a:xfrm>
           <a:prstGeom prst="rect">
@@ -13471,7 +13471,7 @@
           <a:lstStyle/>
           <a:p>
             <a:pPr algn="ctr">
-              <a:defRPr sz="1800" b="1">
+              <a:defRPr sz="2000" b="1">
                 <a:solidFill>
                   <a:srgbClr val="FFFFFF"/>
                 </a:solidFill>
@@ -13492,8 +13492,8 @@
         </p:nvSpPr>
         <p:spPr>
           <a:xfrm>
-            <a:off x="9372599" y="2926080"/>
-            <a:ext cx="2331720" cy="548640"/>
+            <a:off x="9372599" y="3749040"/>
+            <a:ext cx="2331720" cy="457200"/>
           </a:xfrm>
           <a:prstGeom prst="rect">
             <a:avLst/>
@@ -13507,9 +13507,9 @@
           <a:lstStyle/>
           <a:p>
             <a:pPr algn="ctr">
-              <a:defRPr sz="1200" b="0">
-                <a:solidFill>
-                  <a:srgbClr val="6C757D"/>
+              <a:defRPr sz="1500" b="0">
+                <a:solidFill>
+                  <a:srgbClr val="C0C8D6"/>
                 </a:solidFill>
                 <a:latin typeface="Microsoft JhengHei"/>
               </a:defRPr>
@@ -13528,14 +13528,14 @@
         </p:nvSpPr>
         <p:spPr>
           <a:xfrm>
-            <a:off x="548640" y="4023360"/>
-            <a:ext cx="11064240" cy="2011680"/>
+            <a:off x="548640" y="4663440"/>
+            <a:ext cx="11064240" cy="1645920"/>
           </a:xfrm>
           <a:prstGeom prst="roundRect">
             <a:avLst/>
           </a:prstGeom>
           <a:solidFill>
-            <a:srgbClr val="242A40"/>
+            <a:srgbClr val="2B3045"/>
           </a:solidFill>
           <a:ln>
             <a:noFill/>
@@ -13571,7 +13571,7 @@
         </p:nvSpPr>
         <p:spPr>
           <a:xfrm>
-            <a:off x="914400" y="4206240"/>
+            <a:off x="914400" y="4754880"/>
             <a:ext cx="10332720" cy="457200"/>
           </a:xfrm>
           <a:prstGeom prst="rect">
@@ -13586,7 +13586,7 @@
           <a:lstStyle/>
           <a:p>
             <a:pPr algn="l">
-              <a:defRPr sz="1800" b="1">
+              <a:defRPr sz="2000" b="1">
                 <a:solidFill>
                   <a:srgbClr val="00B4D8"/>
                 </a:solidFill>
@@ -13607,7 +13607,7 @@
         </p:nvSpPr>
         <p:spPr>
           <a:xfrm>
-            <a:off x="1097280" y="4754880"/>
+            <a:off x="1097280" y="5303520"/>
             <a:ext cx="10058400" cy="365760"/>
           </a:xfrm>
           <a:prstGeom prst="rect">
@@ -13622,9 +13622,9 @@
           <a:lstStyle/>
           <a:p>
             <a:pPr algn="l">
-              <a:defRPr sz="1400" b="0">
-                <a:solidFill>
-                  <a:srgbClr val="6C757D"/>
+              <a:defRPr sz="1600" b="0">
+                <a:solidFill>
+                  <a:srgbClr val="C0C8D6"/>
                 </a:solidFill>
                 <a:latin typeface="Microsoft JhengHei"/>
               </a:defRPr>
@@ -13643,7 +13643,7 @@
         </p:nvSpPr>
         <p:spPr>
           <a:xfrm>
-            <a:off x="1097280" y="5120640"/>
+            <a:off x="1097280" y="5669280"/>
             <a:ext cx="10058400" cy="365760"/>
           </a:xfrm>
           <a:prstGeom prst="rect">
@@ -13658,9 +13658,9 @@
           <a:lstStyle/>
           <a:p>
             <a:pPr algn="l">
-              <a:defRPr sz="1400" b="0">
-                <a:solidFill>
-                  <a:srgbClr val="6C757D"/>
+              <a:defRPr sz="1600" b="0">
+                <a:solidFill>
+                  <a:srgbClr val="C0C8D6"/>
                 </a:solidFill>
                 <a:latin typeface="Microsoft JhengHei"/>
               </a:defRPr>
@@ -13679,7 +13679,7 @@
         </p:nvSpPr>
         <p:spPr>
           <a:xfrm>
-            <a:off x="1097280" y="5486400"/>
+            <a:off x="1097280" y="6035040"/>
             <a:ext cx="10058400" cy="365760"/>
           </a:xfrm>
           <a:prstGeom prst="rect">
@@ -13694,9 +13694,9 @@
           <a:lstStyle/>
           <a:p>
             <a:pPr algn="l">
-              <a:defRPr sz="1400" b="0">
-                <a:solidFill>
-                  <a:srgbClr val="6C757D"/>
+              <a:defRPr sz="1600" b="0">
+                <a:solidFill>
+                  <a:srgbClr val="C0C8D6"/>
                 </a:solidFill>
                 <a:latin typeface="Microsoft JhengHei"/>
               </a:defRPr>

</xml_diff>